<commit_message>
docs: add an implementation and tools slide, and offer the decks as PowerPoint
The zeroth review gains a slide that says plainly that the project has both a
hardware part and a software part, then lists the tools for each side. The
firmware is built on ESP-IDF in C++, with FreeRTOS underneath; the hardware
side covers Siemens NX, the 3D printer, the soldering bench and the meters.
The contents slide lists it, and now numbers its entries 1. 2. 3. rather than
using citation brackets.

A document in the tracker can now carry one extra file next to the main one,
declared as extra: { label, file }. Both review decks use it to offer the
editable .pptx beside the .pdf that previews in place, so the site hands over
the source and not only the export.

The Phase 4 task is renamed to match the toolchain actually in use. Its id is
unchanged, so any saved progress carries over.
</commit_message>
<xml_diff>
--- a/docs/reviews/zeroth-review/Predictive_BMS_Zeroth_Review.pptx
+++ b/docs/reviews/zeroth-review/Predictive_BMS_Zeroth_Review.pptx
@@ -13,6 +13,7 @@
     <p:sldId id="261" r:id="rId13"/>
     <p:sldId id="262" r:id="rId14"/>
     <p:sldId id="263" r:id="rId15"/>
+    <p:sldId id="264" r:id="rId16"/>
   </p:sldIdLst>
   <p:sldSz cx="12191695" cy="6858000" type="screen4x3"/>
   <p:notesSz cx="6858000" cy="9144000"/>
@@ -964,32 +965,37 @@
           <a:lstStyle/>
           <a:p>
             <a:r>
-              <a:t>These five sources shaped the project. The first explains the physics: the heat</a:t>
-            </a:r>
-          </a:p>
-          <a:p>
-            <a:r>
-              <a:t>inside a cell feeds more reaction, which makes more heat, so the temperature</a:t>
-            </a:r>
-          </a:p>
-          <a:p>
-            <a:r>
-              <a:t>curve bends upward sharply. The second and fourth show that early warning is a</a:t>
-            </a:r>
-          </a:p>
-          <a:p>
-            <a:r>
-              <a:t>known open problem. The third is the closest work to mine and is where the one</a:t>
-            </a:r>
-          </a:p>
-          <a:p>
-            <a:r>
-              <a:t>degree per second figure comes from. The last is the standard my design is aimed</a:t>
-            </a:r>
-          </a:p>
-          <a:p>
-            <a:r>
-              <a:t>at, although I am not claiming certification.</a:t>
+              <a:t>This project is not one or the other. There is a circuit to build and there is</a:t>
+            </a:r>
+          </a:p>
+          <a:p>
+            <a:r>
+              <a:t>firmware to write for it, and neither works without the other. The hardware side</a:t>
+            </a:r>
+          </a:p>
+          <a:p>
+            <a:r>
+              <a:t>is the pack, the sensing, the protection MOSFETs and the enclosure. The software</a:t>
+            </a:r>
+          </a:p>
+          <a:p>
+            <a:r>
+              <a:t>side is the firmware on the ESP32 and the dashboard page. The firmware is</a:t>
+            </a:r>
+          </a:p>
+          <a:p>
+            <a:r>
+              <a:t>written in C++ on ESP-IDF, which is the framework Espressif supply for the</a:t>
+            </a:r>
+          </a:p>
+          <a:p>
+            <a:r>
+              <a:t>ESP32, and it uses FreeRTOS underneath to keep the sensor, safety and telemetry</a:t>
+            </a:r>
+          </a:p>
+          <a:p>
+            <a:r>
+              <a:t>work in separate tasks.</a:t>
             </a:r>
           </a:p>
         </p:txBody>
@@ -1059,22 +1065,32 @@
           <a:lstStyle/>
           <a:p>
             <a:r>
-              <a:t>These are the five sources, numbered in the same order as the survey table on</a:t>
-            </a:r>
-          </a:p>
-          <a:p>
-            <a:r>
-              <a:t>the previous slide. The first four are papers and reviews. The fifth is the</a:t>
-            </a:r>
-          </a:p>
-          <a:p>
-            <a:r>
-              <a:t>Indian standard for sealed lithium cells, which sets out the abuse tests a pack</a:t>
-            </a:r>
-          </a:p>
-          <a:p>
-            <a:r>
-              <a:t>of this kind is expected to survive.</a:t>
+              <a:t>These five sources shaped the project. The first explains the physics: the heat</a:t>
+            </a:r>
+          </a:p>
+          <a:p>
+            <a:r>
+              <a:t>inside a cell feeds more reaction, which makes more heat, so the temperature</a:t>
+            </a:r>
+          </a:p>
+          <a:p>
+            <a:r>
+              <a:t>curve bends upward sharply. The second and fourth show that early warning is a</a:t>
+            </a:r>
+          </a:p>
+          <a:p>
+            <a:r>
+              <a:t>known open problem. The third is the closest work to mine and is where the one</a:t>
+            </a:r>
+          </a:p>
+          <a:p>
+            <a:r>
+              <a:t>degree per second figure comes from. The last is the standard my design is aimed</a:t>
+            </a:r>
+          </a:p>
+          <a:p>
+            <a:r>
+              <a:t>at, although I am not claiming certification.</a:t>
             </a:r>
           </a:p>
         </p:txBody>
@@ -1100,6 +1116,91 @@
 </file>
 
 <file path=ppt/notesSlides/notesSlide8.xml><?xml version="1.0" encoding="utf-8"?>
+<p:notes xmlns:a="http://schemas.openxmlformats.org/drawingml/2006/main" xmlns:p="http://schemas.openxmlformats.org/presentationml/2006/main" xmlns:r="http://schemas.openxmlformats.org/officeDocument/2006/relationships">
+  <p:cSld>
+    <p:spTree>
+      <p:nvGrpSpPr>
+        <p:cNvPr id="1" name=""/>
+        <p:cNvGrpSpPr/>
+        <p:nvPr/>
+      </p:nvGrpSpPr>
+      <p:grpSpPr>
+        <a:xfrm>
+          <a:off x="0" y="0"/>
+          <a:ext cx="0" cy="0"/>
+          <a:chOff x="0" y="0"/>
+          <a:chExt cx="0" cy="0"/>
+        </a:xfrm>
+      </p:grpSpPr>
+      <p:sp>
+        <p:nvSpPr>
+          <p:cNvPr id="2" name="Slide Image Placeholder 1"/>
+          <p:cNvSpPr>
+            <a:spLocks noGrp="1"/>
+          </p:cNvSpPr>
+          <p:nvPr>
+            <p:ph type="sldImg" idx="2"/>
+          </p:nvPr>
+        </p:nvSpPr>
+        <p:spPr/>
+      </p:sp>
+      <p:sp>
+        <p:nvSpPr>
+          <p:cNvPr id="3" name="Notes Placeholder 2"/>
+          <p:cNvSpPr>
+            <a:spLocks noGrp="1"/>
+          </p:cNvSpPr>
+          <p:nvPr>
+            <p:ph type="body" idx="3" sz="quarter"/>
+          </p:nvPr>
+        </p:nvSpPr>
+        <p:spPr/>
+        <p:txBody>
+          <a:bodyPr/>
+          <a:lstStyle/>
+          <a:p>
+            <a:r>
+              <a:t>These are the five sources, numbered in the same order as the survey table on</a:t>
+            </a:r>
+          </a:p>
+          <a:p>
+            <a:r>
+              <a:t>the previous slide. The first four are papers and reviews. The fifth is the</a:t>
+            </a:r>
+          </a:p>
+          <a:p>
+            <a:r>
+              <a:t>Indian standard for sealed lithium cells, which sets out the abuse tests a pack</a:t>
+            </a:r>
+          </a:p>
+          <a:p>
+            <a:r>
+              <a:t>of this kind is expected to survive.</a:t>
+            </a:r>
+          </a:p>
+        </p:txBody>
+      </p:sp>
+      <p:sp>
+        <p:nvSpPr>
+          <p:cNvPr id="4" name="Slide Number Placeholder 3"/>
+          <p:cNvSpPr>
+            <a:spLocks noGrp="1"/>
+          </p:cNvSpPr>
+          <p:nvPr>
+            <p:ph type="sldNum" idx="5" sz="quarter"/>
+          </p:nvPr>
+        </p:nvSpPr>
+        <p:spPr/>
+      </p:sp>
+    </p:spTree>
+  </p:cSld>
+  <p:clrMapOvr>
+    <a:masterClrMapping/>
+  </p:clrMapOvr>
+</p:notes>
+</file>
+
+<file path=ppt/notesSlides/notesSlide9.xml><?xml version="1.0" encoding="utf-8"?>
 <p:notes xmlns:a="http://schemas.openxmlformats.org/drawingml/2006/main" xmlns:p="http://schemas.openxmlformats.org/presentationml/2006/main" xmlns:r="http://schemas.openxmlformats.org/officeDocument/2006/relationships">
   <p:cSld>
     <p:spTree>
@@ -4752,7 +4853,7 @@
                 </a:solidFill>
                 <a:latin typeface="Times New Roman"/>
               </a:rPr>
-              <a:t>[1]  </a:t>
+              <a:t>1.  </a:t>
             </a:r>
             <a:r>
               <a:rPr sz="1800" b="0" i="0" u="none">
@@ -4781,7 +4882,7 @@
                 </a:solidFill>
                 <a:latin typeface="Times New Roman"/>
               </a:rPr>
-              <a:t>[2]  </a:t>
+              <a:t>2.  </a:t>
             </a:r>
             <a:r>
               <a:rPr sz="1800" b="0" i="0" u="none">
@@ -4810,7 +4911,7 @@
                 </a:solidFill>
                 <a:latin typeface="Times New Roman"/>
               </a:rPr>
-              <a:t>[3]  </a:t>
+              <a:t>3.  </a:t>
             </a:r>
             <a:r>
               <a:rPr sz="1800" b="0" i="0" u="none">
@@ -4839,7 +4940,7 @@
                 </a:solidFill>
                 <a:latin typeface="Times New Roman"/>
               </a:rPr>
-              <a:t>[4]  </a:t>
+              <a:t>4.  </a:t>
             </a:r>
             <a:r>
               <a:rPr sz="1800" b="0" i="0" u="none">
@@ -4868,7 +4969,7 @@
                 </a:solidFill>
                 <a:latin typeface="Times New Roman"/>
               </a:rPr>
-              <a:t>[5]  </a:t>
+              <a:t>5.  </a:t>
             </a:r>
             <a:r>
               <a:rPr sz="1800" b="0" i="0" u="none">
@@ -4877,7 +4978,7 @@
                 </a:solidFill>
                 <a:latin typeface="Times New Roman"/>
               </a:rPr>
-              <a:t>Literature Survey</a:t>
+              <a:t>Implementation and Tools</a:t>
             </a:r>
           </a:p>
           <a:p>
@@ -4897,7 +4998,36 @@
                 </a:solidFill>
                 <a:latin typeface="Times New Roman"/>
               </a:rPr>
-              <a:t>[6]  </a:t>
+              <a:t>6.  </a:t>
+            </a:r>
+            <a:r>
+              <a:rPr sz="1800" b="0" i="0" u="none">
+                <a:solidFill>
+                  <a:srgbClr val="000000"/>
+                </a:solidFill>
+                <a:latin typeface="Times New Roman"/>
+              </a:rPr>
+              <a:t>Literature Survey</a:t>
+            </a:r>
+          </a:p>
+          <a:p>
+            <a:pPr marL="384048" indent="-384048">
+              <a:lnSpc>
+                <a:spcPct val="110000"/>
+              </a:lnSpc>
+              <a:spcAft>
+                <a:spcPts val="1300"/>
+              </a:spcAft>
+              <a:buNone/>
+            </a:pPr>
+            <a:r>
+              <a:rPr sz="1800" b="0" i="0" u="none">
+                <a:solidFill>
+                  <a:srgbClr val="000000"/>
+                </a:solidFill>
+                <a:latin typeface="Times New Roman"/>
+              </a:rPr>
+              <a:t>7.  </a:t>
             </a:r>
             <a:r>
               <a:rPr sz="1800" b="0" i="0" u="none">
@@ -5937,7 +6067,7 @@
                 </a:solidFill>
                 <a:latin typeface="Times New Roman"/>
               </a:rPr>
-              <a:t>Literature Survey</a:t>
+              <a:t>Implementation and Tools</a:t>
             </a:r>
           </a:p>
         </p:txBody>
@@ -6042,6 +6172,959 @@
                 <a:latin typeface="Calibri"/>
               </a:rPr>
               <a:t>6</a:t>
+            </a:r>
+          </a:p>
+        </p:txBody>
+      </p:sp>
+      <p:sp>
+        <p:nvSpPr>
+          <p:cNvPr id="7" name="TextBox 6"/>
+          <p:cNvSpPr txBox="1"/>
+          <p:nvPr/>
+        </p:nvSpPr>
+        <p:spPr>
+          <a:xfrm>
+            <a:off x="1168603" y="1316736"/>
+            <a:ext cx="10195560" cy="420624"/>
+          </a:xfrm>
+          <a:prstGeom prst="rect">
+            <a:avLst/>
+          </a:prstGeom>
+          <a:noFill/>
+        </p:spPr>
+        <p:txBody>
+          <a:bodyPr wrap="square" lIns="0" rIns="0" tIns="0" bIns="0">
+            <a:noAutofit/>
+          </a:bodyPr>
+          <a:lstStyle/>
+          <a:p>
+            <a:pPr algn="ctr"/>
+            <a:r>
+              <a:rPr sz="1800" b="1" i="0" u="none">
+                <a:solidFill>
+                  <a:srgbClr val="000000"/>
+                </a:solidFill>
+                <a:latin typeface="Times New Roman"/>
+              </a:rPr>
+              <a:t>This project has a hardware part and a software part. Both are built here.</a:t>
+            </a:r>
+          </a:p>
+        </p:txBody>
+      </p:sp>
+      <p:graphicFrame>
+        <p:nvGraphicFramePr>
+          <p:cNvPr id="8" name="Table 7"/>
+          <p:cNvGraphicFramePr>
+            <a:graphicFrameLocks noGrp="1"/>
+          </p:cNvGraphicFramePr>
+          <p:nvPr/>
+        </p:nvGraphicFramePr>
+        <p:xfrm>
+          <a:off x="975207" y="1956816"/>
+          <a:ext cx="10241280" cy="4187952"/>
+        </p:xfrm>
+        <a:graphic>
+          <a:graphicData uri="http://schemas.openxmlformats.org/drawingml/2006/table">
+            <a:tbl>
+              <a:tblPr firstRow="1">
+                <a:tableStyleId>{5C22544A-7EE6-4342-B048-85BDC9FD1C3A}</a:tableStyleId>
+              </a:tblPr>
+              <a:tblGrid>
+                <a:gridCol w="1737360"/>
+                <a:gridCol w="2926080"/>
+                <a:gridCol w="5577840"/>
+              </a:tblGrid>
+              <a:tr h="418795">
+                <a:tc>
+                  <a:txBody>
+                    <a:bodyPr/>
+                    <a:lstStyle/>
+                    <a:p>
+                      <a:pPr algn="ctr"/>
+                      <a:r>
+                        <a:rPr sz="1500" b="1" i="0" u="none">
+                          <a:solidFill>
+                            <a:srgbClr val="FFFFFF"/>
+                          </a:solidFill>
+                          <a:latin typeface="Times New Roman"/>
+                        </a:rPr>
+                        <a:t>Side</a:t>
+                      </a:r>
+                    </a:p>
+                  </a:txBody>
+                  <a:tcPr anchor="ctr" marL="64008" marR="64008">
+                    <a:solidFill>
+                      <a:srgbClr val="002060"/>
+                    </a:solidFill>
+                  </a:tcPr>
+                </a:tc>
+                <a:tc>
+                  <a:txBody>
+                    <a:bodyPr/>
+                    <a:lstStyle/>
+                    <a:p>
+                      <a:pPr algn="ctr"/>
+                      <a:r>
+                        <a:rPr sz="1500" b="1" i="0" u="none">
+                          <a:solidFill>
+                            <a:srgbClr val="FFFFFF"/>
+                          </a:solidFill>
+                          <a:latin typeface="Times New Roman"/>
+                        </a:rPr>
+                        <a:t>Tool</a:t>
+                      </a:r>
+                    </a:p>
+                  </a:txBody>
+                  <a:tcPr anchor="ctr" marL="64008" marR="64008">
+                    <a:solidFill>
+                      <a:srgbClr val="002060"/>
+                    </a:solidFill>
+                  </a:tcPr>
+                </a:tc>
+                <a:tc>
+                  <a:txBody>
+                    <a:bodyPr/>
+                    <a:lstStyle/>
+                    <a:p>
+                      <a:pPr algn="ctr"/>
+                      <a:r>
+                        <a:rPr sz="1500" b="1" i="0" u="none">
+                          <a:solidFill>
+                            <a:srgbClr val="FFFFFF"/>
+                          </a:solidFill>
+                          <a:latin typeface="Times New Roman"/>
+                        </a:rPr>
+                        <a:t>What it is used for</a:t>
+                      </a:r>
+                    </a:p>
+                  </a:txBody>
+                  <a:tcPr anchor="ctr" marL="64008" marR="64008">
+                    <a:solidFill>
+                      <a:srgbClr val="002060"/>
+                    </a:solidFill>
+                  </a:tcPr>
+                </a:tc>
+              </a:tr>
+              <a:tr h="418795">
+                <a:tc>
+                  <a:txBody>
+                    <a:bodyPr/>
+                    <a:lstStyle/>
+                    <a:p>
+                      <a:pPr algn="ctr"/>
+                      <a:r>
+                        <a:rPr sz="1500" b="0" i="0" u="none">
+                          <a:solidFill>
+                            <a:srgbClr val="000000"/>
+                          </a:solidFill>
+                          <a:latin typeface="Times New Roman"/>
+                        </a:rPr>
+                        <a:t>Hardware</a:t>
+                      </a:r>
+                    </a:p>
+                  </a:txBody>
+                  <a:tcPr anchor="ctr" marL="64008" marR="64008" marT="27432" marB="27432">
+                    <a:solidFill>
+                      <a:srgbClr val="FFFFFF"/>
+                    </a:solidFill>
+                  </a:tcPr>
+                </a:tc>
+                <a:tc>
+                  <a:txBody>
+                    <a:bodyPr/>
+                    <a:lstStyle/>
+                    <a:p>
+                      <a:pPr algn="l"/>
+                      <a:r>
+                        <a:rPr sz="1500" b="0" i="0" u="none">
+                          <a:solidFill>
+                            <a:srgbClr val="000000"/>
+                          </a:solidFill>
+                          <a:latin typeface="Times New Roman"/>
+                        </a:rPr>
+                        <a:t>Siemens NX</a:t>
+                      </a:r>
+                    </a:p>
+                  </a:txBody>
+                  <a:tcPr anchor="ctr" marL="64008" marR="64008" marT="27432" marB="27432">
+                    <a:solidFill>
+                      <a:srgbClr val="FFFFFF"/>
+                    </a:solidFill>
+                  </a:tcPr>
+                </a:tc>
+                <a:tc>
+                  <a:txBody>
+                    <a:bodyPr/>
+                    <a:lstStyle/>
+                    <a:p>
+                      <a:pPr algn="l"/>
+                      <a:r>
+                        <a:rPr sz="1500" b="0" i="0" u="none">
+                          <a:solidFill>
+                            <a:srgbClr val="000000"/>
+                          </a:solidFill>
+                          <a:latin typeface="Times New Roman"/>
+                        </a:rPr>
+                        <a:t>Modelling the enclosure</a:t>
+                      </a:r>
+                    </a:p>
+                  </a:txBody>
+                  <a:tcPr anchor="ctr" marL="64008" marR="64008" marT="27432" marB="27432">
+                    <a:solidFill>
+                      <a:srgbClr val="FFFFFF"/>
+                    </a:solidFill>
+                  </a:tcPr>
+                </a:tc>
+              </a:tr>
+              <a:tr h="418795">
+                <a:tc>
+                  <a:txBody>
+                    <a:bodyPr/>
+                    <a:lstStyle/>
+                    <a:p>
+                      <a:pPr algn="ctr"/>
+                      <a:r>
+                        <a:rPr sz="1500" b="0" i="0" u="none">
+                          <a:solidFill>
+                            <a:srgbClr val="000000"/>
+                          </a:solidFill>
+                          <a:latin typeface="Times New Roman"/>
+                        </a:rPr>
+                        <a:t>Hardware</a:t>
+                      </a:r>
+                    </a:p>
+                  </a:txBody>
+                  <a:tcPr anchor="ctr" marL="64008" marR="64008" marT="27432" marB="27432">
+                    <a:solidFill>
+                      <a:srgbClr val="EDEDED"/>
+                    </a:solidFill>
+                  </a:tcPr>
+                </a:tc>
+                <a:tc>
+                  <a:txBody>
+                    <a:bodyPr/>
+                    <a:lstStyle/>
+                    <a:p>
+                      <a:pPr algn="l"/>
+                      <a:r>
+                        <a:rPr sz="1500" b="0" i="0" u="none">
+                          <a:solidFill>
+                            <a:srgbClr val="000000"/>
+                          </a:solidFill>
+                          <a:latin typeface="Times New Roman"/>
+                        </a:rPr>
+                        <a:t>3D printer, PLA+</a:t>
+                      </a:r>
+                    </a:p>
+                  </a:txBody>
+                  <a:tcPr anchor="ctr" marL="64008" marR="64008" marT="27432" marB="27432">
+                    <a:solidFill>
+                      <a:srgbClr val="EDEDED"/>
+                    </a:solidFill>
+                  </a:tcPr>
+                </a:tc>
+                <a:tc>
+                  <a:txBody>
+                    <a:bodyPr/>
+                    <a:lstStyle/>
+                    <a:p>
+                      <a:pPr algn="l"/>
+                      <a:r>
+                        <a:rPr sz="1500" b="0" i="0" u="none">
+                          <a:solidFill>
+                            <a:srgbClr val="000000"/>
+                          </a:solidFill>
+                          <a:latin typeface="Times New Roman"/>
+                        </a:rPr>
+                        <a:t>Printing the enclosure</a:t>
+                      </a:r>
+                    </a:p>
+                  </a:txBody>
+                  <a:tcPr anchor="ctr" marL="64008" marR="64008" marT="27432" marB="27432">
+                    <a:solidFill>
+                      <a:srgbClr val="EDEDED"/>
+                    </a:solidFill>
+                  </a:tcPr>
+                </a:tc>
+              </a:tr>
+              <a:tr h="418795">
+                <a:tc>
+                  <a:txBody>
+                    <a:bodyPr/>
+                    <a:lstStyle/>
+                    <a:p>
+                      <a:pPr algn="ctr"/>
+                      <a:r>
+                        <a:rPr sz="1500" b="0" i="0" u="none">
+                          <a:solidFill>
+                            <a:srgbClr val="000000"/>
+                          </a:solidFill>
+                          <a:latin typeface="Times New Roman"/>
+                        </a:rPr>
+                        <a:t>Hardware</a:t>
+                      </a:r>
+                    </a:p>
+                  </a:txBody>
+                  <a:tcPr anchor="ctr" marL="64008" marR="64008" marT="27432" marB="27432">
+                    <a:solidFill>
+                      <a:srgbClr val="FFFFFF"/>
+                    </a:solidFill>
+                  </a:tcPr>
+                </a:tc>
+                <a:tc>
+                  <a:txBody>
+                    <a:bodyPr/>
+                    <a:lstStyle/>
+                    <a:p>
+                      <a:pPr algn="l"/>
+                      <a:r>
+                        <a:rPr sz="1500" b="0" i="0" u="none">
+                          <a:solidFill>
+                            <a:srgbClr val="000000"/>
+                          </a:solidFill>
+                          <a:latin typeface="Times New Roman"/>
+                        </a:rPr>
+                        <a:t>Soldering station</a:t>
+                      </a:r>
+                    </a:p>
+                  </a:txBody>
+                  <a:tcPr anchor="ctr" marL="64008" marR="64008" marT="27432" marB="27432">
+                    <a:solidFill>
+                      <a:srgbClr val="FFFFFF"/>
+                    </a:solidFill>
+                  </a:tcPr>
+                </a:tc>
+                <a:tc>
+                  <a:txBody>
+                    <a:bodyPr/>
+                    <a:lstStyle/>
+                    <a:p>
+                      <a:pPr algn="l"/>
+                      <a:r>
+                        <a:rPr sz="1500" b="0" i="0" u="none">
+                          <a:solidFill>
+                            <a:srgbClr val="000000"/>
+                          </a:solidFill>
+                          <a:latin typeface="Times New Roman"/>
+                        </a:rPr>
+                        <a:t>Building the board, perfboard first, then a soldered PCB</a:t>
+                      </a:r>
+                    </a:p>
+                  </a:txBody>
+                  <a:tcPr anchor="ctr" marL="64008" marR="64008" marT="27432" marB="27432">
+                    <a:solidFill>
+                      <a:srgbClr val="FFFFFF"/>
+                    </a:solidFill>
+                  </a:tcPr>
+                </a:tc>
+              </a:tr>
+              <a:tr h="418795">
+                <a:tc>
+                  <a:txBody>
+                    <a:bodyPr/>
+                    <a:lstStyle/>
+                    <a:p>
+                      <a:pPr algn="ctr"/>
+                      <a:r>
+                        <a:rPr sz="1500" b="0" i="0" u="none">
+                          <a:solidFill>
+                            <a:srgbClr val="000000"/>
+                          </a:solidFill>
+                          <a:latin typeface="Times New Roman"/>
+                        </a:rPr>
+                        <a:t>Hardware</a:t>
+                      </a:r>
+                    </a:p>
+                  </a:txBody>
+                  <a:tcPr anchor="ctr" marL="64008" marR="64008" marT="27432" marB="27432">
+                    <a:solidFill>
+                      <a:srgbClr val="EDEDED"/>
+                    </a:solidFill>
+                  </a:tcPr>
+                </a:tc>
+                <a:tc>
+                  <a:txBody>
+                    <a:bodyPr/>
+                    <a:lstStyle/>
+                    <a:p>
+                      <a:pPr algn="l"/>
+                      <a:r>
+                        <a:rPr sz="1500" b="0" i="0" u="none">
+                          <a:solidFill>
+                            <a:srgbClr val="000000"/>
+                          </a:solidFill>
+                          <a:latin typeface="Times New Roman"/>
+                        </a:rPr>
+                        <a:t>Multimeter, bench supply</a:t>
+                      </a:r>
+                    </a:p>
+                  </a:txBody>
+                  <a:tcPr anchor="ctr" marL="64008" marR="64008" marT="27432" marB="27432">
+                    <a:solidFill>
+                      <a:srgbClr val="EDEDED"/>
+                    </a:solidFill>
+                  </a:tcPr>
+                </a:tc>
+                <a:tc>
+                  <a:txBody>
+                    <a:bodyPr/>
+                    <a:lstStyle/>
+                    <a:p>
+                      <a:pPr algn="l"/>
+                      <a:r>
+                        <a:rPr sz="1500" b="0" i="0" u="none">
+                          <a:solidFill>
+                            <a:srgbClr val="000000"/>
+                          </a:solidFill>
+                          <a:latin typeface="Times New Roman"/>
+                        </a:rPr>
+                        <a:t>Measuring and testing the circuit</a:t>
+                      </a:r>
+                    </a:p>
+                  </a:txBody>
+                  <a:tcPr anchor="ctr" marL="64008" marR="64008" marT="27432" marB="27432">
+                    <a:solidFill>
+                      <a:srgbClr val="EDEDED"/>
+                    </a:solidFill>
+                  </a:tcPr>
+                </a:tc>
+              </a:tr>
+              <a:tr h="418795">
+                <a:tc>
+                  <a:txBody>
+                    <a:bodyPr/>
+                    <a:lstStyle/>
+                    <a:p>
+                      <a:pPr algn="ctr"/>
+                      <a:r>
+                        <a:rPr sz="1500" b="0" i="0" u="none">
+                          <a:solidFill>
+                            <a:srgbClr val="000000"/>
+                          </a:solidFill>
+                          <a:latin typeface="Times New Roman"/>
+                        </a:rPr>
+                        <a:t>Software</a:t>
+                      </a:r>
+                    </a:p>
+                  </a:txBody>
+                  <a:tcPr anchor="ctr" marL="64008" marR="64008" marT="27432" marB="27432">
+                    <a:solidFill>
+                      <a:srgbClr val="FFFFFF"/>
+                    </a:solidFill>
+                  </a:tcPr>
+                </a:tc>
+                <a:tc>
+                  <a:txBody>
+                    <a:bodyPr/>
+                    <a:lstStyle/>
+                    <a:p>
+                      <a:pPr algn="l"/>
+                      <a:r>
+                        <a:rPr sz="1500" b="0" i="0" u="none">
+                          <a:solidFill>
+                            <a:srgbClr val="000000"/>
+                          </a:solidFill>
+                          <a:latin typeface="Times New Roman"/>
+                        </a:rPr>
+                        <a:t>ESP-IDF</a:t>
+                      </a:r>
+                    </a:p>
+                  </a:txBody>
+                  <a:tcPr anchor="ctr" marL="64008" marR="64008" marT="27432" marB="27432">
+                    <a:solidFill>
+                      <a:srgbClr val="FFFFFF"/>
+                    </a:solidFill>
+                  </a:tcPr>
+                </a:tc>
+                <a:tc>
+                  <a:txBody>
+                    <a:bodyPr/>
+                    <a:lstStyle/>
+                    <a:p>
+                      <a:pPr algn="l"/>
+                      <a:r>
+                        <a:rPr sz="1500" b="0" i="0" u="none">
+                          <a:solidFill>
+                            <a:srgbClr val="000000"/>
+                          </a:solidFill>
+                          <a:latin typeface="Times New Roman"/>
+                        </a:rPr>
+                        <a:t>The framework the firmware is built on</a:t>
+                      </a:r>
+                    </a:p>
+                  </a:txBody>
+                  <a:tcPr anchor="ctr" marL="64008" marR="64008" marT="27432" marB="27432">
+                    <a:solidFill>
+                      <a:srgbClr val="FFFFFF"/>
+                    </a:solidFill>
+                  </a:tcPr>
+                </a:tc>
+              </a:tr>
+              <a:tr h="418795">
+                <a:tc>
+                  <a:txBody>
+                    <a:bodyPr/>
+                    <a:lstStyle/>
+                    <a:p>
+                      <a:pPr algn="ctr"/>
+                      <a:r>
+                        <a:rPr sz="1500" b="0" i="0" u="none">
+                          <a:solidFill>
+                            <a:srgbClr val="000000"/>
+                          </a:solidFill>
+                          <a:latin typeface="Times New Roman"/>
+                        </a:rPr>
+                        <a:t>Software</a:t>
+                      </a:r>
+                    </a:p>
+                  </a:txBody>
+                  <a:tcPr anchor="ctr" marL="64008" marR="64008" marT="27432" marB="27432">
+                    <a:solidFill>
+                      <a:srgbClr val="EDEDED"/>
+                    </a:solidFill>
+                  </a:tcPr>
+                </a:tc>
+                <a:tc>
+                  <a:txBody>
+                    <a:bodyPr/>
+                    <a:lstStyle/>
+                    <a:p>
+                      <a:pPr algn="l"/>
+                      <a:r>
+                        <a:rPr sz="1500" b="0" i="0" u="none">
+                          <a:solidFill>
+                            <a:srgbClr val="000000"/>
+                          </a:solidFill>
+                          <a:latin typeface="Times New Roman"/>
+                        </a:rPr>
+                        <a:t>C++</a:t>
+                      </a:r>
+                    </a:p>
+                  </a:txBody>
+                  <a:tcPr anchor="ctr" marL="64008" marR="64008" marT="27432" marB="27432">
+                    <a:solidFill>
+                      <a:srgbClr val="EDEDED"/>
+                    </a:solidFill>
+                  </a:tcPr>
+                </a:tc>
+                <a:tc>
+                  <a:txBody>
+                    <a:bodyPr/>
+                    <a:lstStyle/>
+                    <a:p>
+                      <a:pPr algn="l"/>
+                      <a:r>
+                        <a:rPr sz="1500" b="0" i="0" u="none">
+                          <a:solidFill>
+                            <a:srgbClr val="000000"/>
+                          </a:solidFill>
+                          <a:latin typeface="Times New Roman"/>
+                        </a:rPr>
+                        <a:t>The language the firmware is written in</a:t>
+                      </a:r>
+                    </a:p>
+                  </a:txBody>
+                  <a:tcPr anchor="ctr" marL="64008" marR="64008" marT="27432" marB="27432">
+                    <a:solidFill>
+                      <a:srgbClr val="EDEDED"/>
+                    </a:solidFill>
+                  </a:tcPr>
+                </a:tc>
+              </a:tr>
+              <a:tr h="418795">
+                <a:tc>
+                  <a:txBody>
+                    <a:bodyPr/>
+                    <a:lstStyle/>
+                    <a:p>
+                      <a:pPr algn="ctr"/>
+                      <a:r>
+                        <a:rPr sz="1500" b="0" i="0" u="none">
+                          <a:solidFill>
+                            <a:srgbClr val="000000"/>
+                          </a:solidFill>
+                          <a:latin typeface="Times New Roman"/>
+                        </a:rPr>
+                        <a:t>Software</a:t>
+                      </a:r>
+                    </a:p>
+                  </a:txBody>
+                  <a:tcPr anchor="ctr" marL="64008" marR="64008" marT="27432" marB="27432">
+                    <a:solidFill>
+                      <a:srgbClr val="FFFFFF"/>
+                    </a:solidFill>
+                  </a:tcPr>
+                </a:tc>
+                <a:tc>
+                  <a:txBody>
+                    <a:bodyPr/>
+                    <a:lstStyle/>
+                    <a:p>
+                      <a:pPr algn="l"/>
+                      <a:r>
+                        <a:rPr sz="1500" b="0" i="0" u="none">
+                          <a:solidFill>
+                            <a:srgbClr val="000000"/>
+                          </a:solidFill>
+                          <a:latin typeface="Times New Roman"/>
+                        </a:rPr>
+                        <a:t>FreeRTOS</a:t>
+                      </a:r>
+                    </a:p>
+                  </a:txBody>
+                  <a:tcPr anchor="ctr" marL="64008" marR="64008" marT="27432" marB="27432">
+                    <a:solidFill>
+                      <a:srgbClr val="FFFFFF"/>
+                    </a:solidFill>
+                  </a:tcPr>
+                </a:tc>
+                <a:tc>
+                  <a:txBody>
+                    <a:bodyPr/>
+                    <a:lstStyle/>
+                    <a:p>
+                      <a:pPr algn="l"/>
+                      <a:r>
+                        <a:rPr sz="1500" b="0" i="0" u="none">
+                          <a:solidFill>
+                            <a:srgbClr val="000000"/>
+                          </a:solidFill>
+                          <a:latin typeface="Times New Roman"/>
+                        </a:rPr>
+                        <a:t>Running the sensor, safety and telemetry tasks</a:t>
+                      </a:r>
+                    </a:p>
+                  </a:txBody>
+                  <a:tcPr anchor="ctr" marL="64008" marR="64008" marT="27432" marB="27432">
+                    <a:solidFill>
+                      <a:srgbClr val="FFFFFF"/>
+                    </a:solidFill>
+                  </a:tcPr>
+                </a:tc>
+              </a:tr>
+              <a:tr h="418795">
+                <a:tc>
+                  <a:txBody>
+                    <a:bodyPr/>
+                    <a:lstStyle/>
+                    <a:p>
+                      <a:pPr algn="ctr"/>
+                      <a:r>
+                        <a:rPr sz="1500" b="0" i="0" u="none">
+                          <a:solidFill>
+                            <a:srgbClr val="000000"/>
+                          </a:solidFill>
+                          <a:latin typeface="Times New Roman"/>
+                        </a:rPr>
+                        <a:t>Software</a:t>
+                      </a:r>
+                    </a:p>
+                  </a:txBody>
+                  <a:tcPr anchor="ctr" marL="64008" marR="64008" marT="27432" marB="27432">
+                    <a:solidFill>
+                      <a:srgbClr val="EDEDED"/>
+                    </a:solidFill>
+                  </a:tcPr>
+                </a:tc>
+                <a:tc>
+                  <a:txBody>
+                    <a:bodyPr/>
+                    <a:lstStyle/>
+                    <a:p>
+                      <a:pPr algn="l"/>
+                      <a:r>
+                        <a:rPr sz="1500" b="0" i="0" u="none">
+                          <a:solidFill>
+                            <a:srgbClr val="000000"/>
+                          </a:solidFill>
+                          <a:latin typeface="Times New Roman"/>
+                        </a:rPr>
+                        <a:t>HTML, CSS, JavaScript</a:t>
+                      </a:r>
+                    </a:p>
+                  </a:txBody>
+                  <a:tcPr anchor="ctr" marL="64008" marR="64008" marT="27432" marB="27432">
+                    <a:solidFill>
+                      <a:srgbClr val="EDEDED"/>
+                    </a:solidFill>
+                  </a:tcPr>
+                </a:tc>
+                <a:tc>
+                  <a:txBody>
+                    <a:bodyPr/>
+                    <a:lstStyle/>
+                    <a:p>
+                      <a:pPr algn="l"/>
+                      <a:r>
+                        <a:rPr sz="1500" b="0" i="0" u="none">
+                          <a:solidFill>
+                            <a:srgbClr val="000000"/>
+                          </a:solidFill>
+                          <a:latin typeface="Times New Roman"/>
+                        </a:rPr>
+                        <a:t>The dashboard page in the browser</a:t>
+                      </a:r>
+                    </a:p>
+                  </a:txBody>
+                  <a:tcPr anchor="ctr" marL="64008" marR="64008" marT="27432" marB="27432">
+                    <a:solidFill>
+                      <a:srgbClr val="EDEDED"/>
+                    </a:solidFill>
+                  </a:tcPr>
+                </a:tc>
+              </a:tr>
+              <a:tr h="418797">
+                <a:tc>
+                  <a:txBody>
+                    <a:bodyPr/>
+                    <a:lstStyle/>
+                    <a:p>
+                      <a:pPr algn="ctr"/>
+                      <a:r>
+                        <a:rPr sz="1500" b="0" i="0" u="none">
+                          <a:solidFill>
+                            <a:srgbClr val="000000"/>
+                          </a:solidFill>
+                          <a:latin typeface="Times New Roman"/>
+                        </a:rPr>
+                        <a:t>Software</a:t>
+                      </a:r>
+                    </a:p>
+                  </a:txBody>
+                  <a:tcPr anchor="ctr" marL="64008" marR="64008" marT="27432" marB="27432">
+                    <a:solidFill>
+                      <a:srgbClr val="FFFFFF"/>
+                    </a:solidFill>
+                  </a:tcPr>
+                </a:tc>
+                <a:tc>
+                  <a:txBody>
+                    <a:bodyPr/>
+                    <a:lstStyle/>
+                    <a:p>
+                      <a:pPr algn="l"/>
+                      <a:r>
+                        <a:rPr sz="1500" b="0" i="0" u="none">
+                          <a:solidFill>
+                            <a:srgbClr val="000000"/>
+                          </a:solidFill>
+                          <a:latin typeface="Times New Roman"/>
+                        </a:rPr>
+                        <a:t>Git and GitHub</a:t>
+                      </a:r>
+                    </a:p>
+                  </a:txBody>
+                  <a:tcPr anchor="ctr" marL="64008" marR="64008" marT="27432" marB="27432">
+                    <a:solidFill>
+                      <a:srgbClr val="FFFFFF"/>
+                    </a:solidFill>
+                  </a:tcPr>
+                </a:tc>
+                <a:tc>
+                  <a:txBody>
+                    <a:bodyPr/>
+                    <a:lstStyle/>
+                    <a:p>
+                      <a:pPr algn="l"/>
+                      <a:r>
+                        <a:rPr sz="1500" b="0" i="0" u="none">
+                          <a:solidFill>
+                            <a:srgbClr val="000000"/>
+                          </a:solidFill>
+                          <a:latin typeface="Times New Roman"/>
+                        </a:rPr>
+                        <a:t>Keeping the code and the documents</a:t>
+                      </a:r>
+                    </a:p>
+                  </a:txBody>
+                  <a:tcPr anchor="ctr" marL="64008" marR="64008" marT="27432" marB="27432">
+                    <a:solidFill>
+                      <a:srgbClr val="FFFFFF"/>
+                    </a:solidFill>
+                  </a:tcPr>
+                </a:tc>
+              </a:tr>
+            </a:tbl>
+          </a:graphicData>
+        </a:graphic>
+      </p:graphicFrame>
+    </p:spTree>
+  </p:cSld>
+  <p:clrMapOvr>
+    <a:masterClrMapping/>
+  </p:clrMapOvr>
+</p:sld>
+</file>
+
+<file path=ppt/slides/slide7.xml><?xml version="1.0" encoding="utf-8"?>
+<p:sld xmlns:a="http://schemas.openxmlformats.org/drawingml/2006/main" xmlns:p="http://schemas.openxmlformats.org/presentationml/2006/main" xmlns:r="http://schemas.openxmlformats.org/officeDocument/2006/relationships">
+  <p:cSld>
+    <p:spTree>
+      <p:nvGrpSpPr>
+        <p:cNvPr id="1" name=""/>
+        <p:cNvGrpSpPr/>
+        <p:nvPr/>
+      </p:nvGrpSpPr>
+      <p:grpSpPr/>
+      <p:pic>
+        <p:nvPicPr>
+          <p:cNvPr id="2" name="Picture 1" descr="logo.png"/>
+          <p:cNvPicPr>
+            <a:picLocks noChangeAspect="1"/>
+          </p:cNvPicPr>
+          <p:nvPr/>
+        </p:nvPicPr>
+        <p:blipFill>
+          <a:blip r:embed="rId2"/>
+          <a:stretch>
+            <a:fillRect/>
+          </a:stretch>
+        </p:blipFill>
+        <p:spPr>
+          <a:xfrm>
+            <a:off x="286207" y="109728"/>
+            <a:ext cx="646480" cy="950976"/>
+          </a:xfrm>
+          <a:prstGeom prst="rect">
+            <a:avLst/>
+          </a:prstGeom>
+        </p:spPr>
+      </p:pic>
+      <p:sp>
+        <p:nvSpPr>
+          <p:cNvPr id="3" name="TextBox 2"/>
+          <p:cNvSpPr txBox="1"/>
+          <p:nvPr/>
+        </p:nvSpPr>
+        <p:spPr>
+          <a:xfrm>
+            <a:off x="1188720" y="384048"/>
+            <a:ext cx="9814255" cy="548640"/>
+          </a:xfrm>
+          <a:prstGeom prst="rect">
+            <a:avLst/>
+          </a:prstGeom>
+          <a:noFill/>
+        </p:spPr>
+        <p:txBody>
+          <a:bodyPr wrap="square" lIns="0" rIns="0" tIns="0" bIns="0">
+            <a:noAutofit/>
+          </a:bodyPr>
+          <a:lstStyle/>
+          <a:p>
+            <a:pPr algn="ctr"/>
+            <a:r>
+              <a:rPr sz="2400" b="1" i="0" u="sng">
+                <a:solidFill>
+                  <a:srgbClr val="000000"/>
+                </a:solidFill>
+                <a:latin typeface="Times New Roman"/>
+              </a:rPr>
+              <a:t>Literature Survey</a:t>
+            </a:r>
+          </a:p>
+        </p:txBody>
+      </p:sp>
+      <p:sp>
+        <p:nvSpPr>
+          <p:cNvPr id="4" name="TextBox 3"/>
+          <p:cNvSpPr txBox="1"/>
+          <p:nvPr/>
+        </p:nvSpPr>
+        <p:spPr>
+          <a:xfrm>
+            <a:off x="929944" y="6355080"/>
+            <a:ext cx="2286000" cy="292608"/>
+          </a:xfrm>
+          <a:prstGeom prst="rect">
+            <a:avLst/>
+          </a:prstGeom>
+          <a:noFill/>
+        </p:spPr>
+        <p:txBody>
+          <a:bodyPr wrap="square" lIns="0" rIns="0" tIns="0" bIns="0">
+            <a:noAutofit/>
+          </a:bodyPr>
+          <a:lstStyle/>
+          <a:p>
+            <a:r>
+              <a:rPr sz="1200" b="0" i="0" u="none">
+                <a:solidFill>
+                  <a:srgbClr val="898989"/>
+                </a:solidFill>
+                <a:latin typeface="Calibri"/>
+              </a:rPr>
+              <a:t>22-07-2026</a:t>
+            </a:r>
+          </a:p>
+        </p:txBody>
+      </p:sp>
+      <p:sp>
+        <p:nvSpPr>
+          <p:cNvPr id="5" name="TextBox 4"/>
+          <p:cNvSpPr txBox="1"/>
+          <p:nvPr/>
+        </p:nvSpPr>
+        <p:spPr>
+          <a:xfrm>
+            <a:off x="3931920" y="6355080"/>
+            <a:ext cx="4297680" cy="292608"/>
+          </a:xfrm>
+          <a:prstGeom prst="rect">
+            <a:avLst/>
+          </a:prstGeom>
+          <a:noFill/>
+        </p:spPr>
+        <p:txBody>
+          <a:bodyPr wrap="square" lIns="0" rIns="0" tIns="0" bIns="0">
+            <a:noAutofit/>
+          </a:bodyPr>
+          <a:lstStyle/>
+          <a:p>
+            <a:pPr algn="ctr"/>
+            <a:r>
+              <a:rPr sz="1200" b="0" i="0" u="none">
+                <a:solidFill>
+                  <a:srgbClr val="898989"/>
+                </a:solidFill>
+                <a:latin typeface="Calibri"/>
+              </a:rPr>
+              <a:t>Zeroth Review-2026-27</a:t>
+            </a:r>
+          </a:p>
+        </p:txBody>
+      </p:sp>
+      <p:sp>
+        <p:nvSpPr>
+          <p:cNvPr id="6" name="TextBox 5"/>
+          <p:cNvSpPr txBox="1"/>
+          <p:nvPr/>
+        </p:nvSpPr>
+        <p:spPr>
+          <a:xfrm>
+            <a:off x="10058400" y="6355080"/>
+            <a:ext cx="1204264" cy="292608"/>
+          </a:xfrm>
+          <a:prstGeom prst="rect">
+            <a:avLst/>
+          </a:prstGeom>
+          <a:noFill/>
+        </p:spPr>
+        <p:txBody>
+          <a:bodyPr wrap="square" lIns="0" rIns="0" tIns="0" bIns="0">
+            <a:noAutofit/>
+          </a:bodyPr>
+          <a:lstStyle/>
+          <a:p>
+            <a:pPr algn="r"/>
+            <a:r>
+              <a:rPr sz="1200" b="0" i="0" u="none">
+                <a:solidFill>
+                  <a:srgbClr val="898989"/>
+                </a:solidFill>
+                <a:latin typeface="Calibri"/>
+              </a:rPr>
+              <a:t>7</a:t>
             </a:r>
           </a:p>
         </p:txBody>
@@ -6368,355 +7451,6 @@
 </p:sld>
 </file>
 
-<file path=ppt/slides/slide7.xml><?xml version="1.0" encoding="utf-8"?>
-<p:sld xmlns:a="http://schemas.openxmlformats.org/drawingml/2006/main" xmlns:p="http://schemas.openxmlformats.org/presentationml/2006/main" xmlns:r="http://schemas.openxmlformats.org/officeDocument/2006/relationships">
-  <p:cSld>
-    <p:spTree>
-      <p:nvGrpSpPr>
-        <p:cNvPr id="1" name=""/>
-        <p:cNvGrpSpPr/>
-        <p:nvPr/>
-      </p:nvGrpSpPr>
-      <p:grpSpPr/>
-      <p:pic>
-        <p:nvPicPr>
-          <p:cNvPr id="2" name="Picture 1" descr="logo.png"/>
-          <p:cNvPicPr>
-            <a:picLocks noChangeAspect="1"/>
-          </p:cNvPicPr>
-          <p:nvPr/>
-        </p:nvPicPr>
-        <p:blipFill>
-          <a:blip r:embed="rId2"/>
-          <a:stretch>
-            <a:fillRect/>
-          </a:stretch>
-        </p:blipFill>
-        <p:spPr>
-          <a:xfrm>
-            <a:off x="286207" y="109728"/>
-            <a:ext cx="646480" cy="950976"/>
-          </a:xfrm>
-          <a:prstGeom prst="rect">
-            <a:avLst/>
-          </a:prstGeom>
-        </p:spPr>
-      </p:pic>
-      <p:sp>
-        <p:nvSpPr>
-          <p:cNvPr id="3" name="TextBox 2"/>
-          <p:cNvSpPr txBox="1"/>
-          <p:nvPr/>
-        </p:nvSpPr>
-        <p:spPr>
-          <a:xfrm>
-            <a:off x="1188720" y="384048"/>
-            <a:ext cx="9814255" cy="548640"/>
-          </a:xfrm>
-          <a:prstGeom prst="rect">
-            <a:avLst/>
-          </a:prstGeom>
-          <a:noFill/>
-        </p:spPr>
-        <p:txBody>
-          <a:bodyPr wrap="square" lIns="0" rIns="0" tIns="0" bIns="0">
-            <a:noAutofit/>
-          </a:bodyPr>
-          <a:lstStyle/>
-          <a:p>
-            <a:pPr algn="ctr"/>
-            <a:r>
-              <a:rPr sz="2400" b="1" i="0" u="sng">
-                <a:solidFill>
-                  <a:srgbClr val="000000"/>
-                </a:solidFill>
-                <a:latin typeface="Times New Roman"/>
-              </a:rPr>
-              <a:t>References</a:t>
-            </a:r>
-          </a:p>
-        </p:txBody>
-      </p:sp>
-      <p:sp>
-        <p:nvSpPr>
-          <p:cNvPr id="4" name="TextBox 3"/>
-          <p:cNvSpPr txBox="1"/>
-          <p:nvPr/>
-        </p:nvSpPr>
-        <p:spPr>
-          <a:xfrm>
-            <a:off x="929944" y="6355080"/>
-            <a:ext cx="2286000" cy="292608"/>
-          </a:xfrm>
-          <a:prstGeom prst="rect">
-            <a:avLst/>
-          </a:prstGeom>
-          <a:noFill/>
-        </p:spPr>
-        <p:txBody>
-          <a:bodyPr wrap="square" lIns="0" rIns="0" tIns="0" bIns="0">
-            <a:noAutofit/>
-          </a:bodyPr>
-          <a:lstStyle/>
-          <a:p>
-            <a:r>
-              <a:rPr sz="1200" b="0" i="0" u="none">
-                <a:solidFill>
-                  <a:srgbClr val="898989"/>
-                </a:solidFill>
-                <a:latin typeface="Calibri"/>
-              </a:rPr>
-              <a:t>22-07-2026</a:t>
-            </a:r>
-          </a:p>
-        </p:txBody>
-      </p:sp>
-      <p:sp>
-        <p:nvSpPr>
-          <p:cNvPr id="5" name="TextBox 4"/>
-          <p:cNvSpPr txBox="1"/>
-          <p:nvPr/>
-        </p:nvSpPr>
-        <p:spPr>
-          <a:xfrm>
-            <a:off x="3931920" y="6355080"/>
-            <a:ext cx="4297680" cy="292608"/>
-          </a:xfrm>
-          <a:prstGeom prst="rect">
-            <a:avLst/>
-          </a:prstGeom>
-          <a:noFill/>
-        </p:spPr>
-        <p:txBody>
-          <a:bodyPr wrap="square" lIns="0" rIns="0" tIns="0" bIns="0">
-            <a:noAutofit/>
-          </a:bodyPr>
-          <a:lstStyle/>
-          <a:p>
-            <a:pPr algn="ctr"/>
-            <a:r>
-              <a:rPr sz="1200" b="0" i="0" u="none">
-                <a:solidFill>
-                  <a:srgbClr val="898989"/>
-                </a:solidFill>
-                <a:latin typeface="Calibri"/>
-              </a:rPr>
-              <a:t>Zeroth Review-2026-27</a:t>
-            </a:r>
-          </a:p>
-        </p:txBody>
-      </p:sp>
-      <p:sp>
-        <p:nvSpPr>
-          <p:cNvPr id="6" name="TextBox 5"/>
-          <p:cNvSpPr txBox="1"/>
-          <p:nvPr/>
-        </p:nvSpPr>
-        <p:spPr>
-          <a:xfrm>
-            <a:off x="10058400" y="6355080"/>
-            <a:ext cx="1204264" cy="292608"/>
-          </a:xfrm>
-          <a:prstGeom prst="rect">
-            <a:avLst/>
-          </a:prstGeom>
-          <a:noFill/>
-        </p:spPr>
-        <p:txBody>
-          <a:bodyPr wrap="square" lIns="0" rIns="0" tIns="0" bIns="0">
-            <a:noAutofit/>
-          </a:bodyPr>
-          <a:lstStyle/>
-          <a:p>
-            <a:pPr algn="r"/>
-            <a:r>
-              <a:rPr sz="1200" b="0" i="0" u="none">
-                <a:solidFill>
-                  <a:srgbClr val="898989"/>
-                </a:solidFill>
-                <a:latin typeface="Calibri"/>
-              </a:rPr>
-              <a:t>7</a:t>
-            </a:r>
-          </a:p>
-        </p:txBody>
-      </p:sp>
-      <p:sp>
-        <p:nvSpPr>
-          <p:cNvPr id="7" name="TextBox 6"/>
-          <p:cNvSpPr txBox="1"/>
-          <p:nvPr/>
-        </p:nvSpPr>
-        <p:spPr>
-          <a:xfrm>
-            <a:off x="1168603" y="1389888"/>
-            <a:ext cx="10195560" cy="4754879"/>
-          </a:xfrm>
-          <a:prstGeom prst="rect">
-            <a:avLst/>
-          </a:prstGeom>
-          <a:noFill/>
-        </p:spPr>
-        <p:txBody>
-          <a:bodyPr wrap="square" lIns="0" rIns="0" tIns="0" bIns="0">
-            <a:noAutofit/>
-          </a:bodyPr>
-          <a:lstStyle/>
-          <a:p>
-            <a:pPr marL="384048" indent="-384048">
-              <a:lnSpc>
-                <a:spcPct val="110000"/>
-              </a:lnSpc>
-              <a:spcAft>
-                <a:spcPts val="2000"/>
-              </a:spcAft>
-              <a:buNone/>
-            </a:pPr>
-            <a:r>
-              <a:rPr sz="1400" b="0" i="0" u="none">
-                <a:solidFill>
-                  <a:srgbClr val="000000"/>
-                </a:solidFill>
-                <a:latin typeface="Times New Roman"/>
-              </a:rPr>
-              <a:t>[1]  </a:t>
-            </a:r>
-            <a:r>
-              <a:rPr sz="1400" b="0" i="0" u="none">
-                <a:solidFill>
-                  <a:srgbClr val="000000"/>
-                </a:solidFill>
-                <a:latin typeface="Times New Roman"/>
-              </a:rPr>
-              <a:t>X. Feng, M. Ouyang, X. Liu, L. Lu, Y. Xia and X. He, “Thermal runaway mechanism of lithium ion battery for electric vehicles: A review,” Energy Storage Materials, vol. 10, pp. 246–267, 2018.</a:t>
-            </a:r>
-          </a:p>
-          <a:p>
-            <a:pPr marL="384048" indent="-384048">
-              <a:lnSpc>
-                <a:spcPct val="110000"/>
-              </a:lnSpc>
-              <a:spcAft>
-                <a:spcPts val="2000"/>
-              </a:spcAft>
-              <a:buNone/>
-            </a:pPr>
-            <a:r>
-              <a:rPr sz="1400" b="0" i="0" u="none">
-                <a:solidFill>
-                  <a:srgbClr val="000000"/>
-                </a:solidFill>
-                <a:latin typeface="Times New Roman"/>
-              </a:rPr>
-              <a:t>[2]  </a:t>
-            </a:r>
-            <a:r>
-              <a:rPr sz="1400" b="0" i="0" u="none">
-                <a:solidFill>
-                  <a:srgbClr val="000000"/>
-                </a:solidFill>
-                <a:latin typeface="Times New Roman"/>
-              </a:rPr>
-              <a:t>X. Zhang, S. Chen, J. Zhu et al., “A critical review of thermal runaway prediction and early-warning methods for lithium-ion batteries,” Energy Material Advances, vol. 4, art. 0008, 2023.</a:t>
-            </a:r>
-          </a:p>
-          <a:p>
-            <a:pPr marL="384048" indent="-384048">
-              <a:lnSpc>
-                <a:spcPct val="110000"/>
-              </a:lnSpc>
-              <a:spcAft>
-                <a:spcPts val="2000"/>
-              </a:spcAft>
-              <a:buNone/>
-            </a:pPr>
-            <a:r>
-              <a:rPr sz="1400" b="0" i="0" u="none">
-                <a:solidFill>
-                  <a:srgbClr val="000000"/>
-                </a:solidFill>
-                <a:latin typeface="Times New Roman"/>
-              </a:rPr>
-              <a:t>[3]  </a:t>
-            </a:r>
-            <a:r>
-              <a:rPr sz="1400" b="0" i="0" u="none">
-                <a:solidFill>
-                  <a:srgbClr val="000000"/>
-                </a:solidFill>
-                <a:latin typeface="Times New Roman"/>
-              </a:rPr>
-              <a:t>Q. Chen, Y. He, N. Fang and G. Yu, “A combined data-driven and model-based algorithm for accurate battery thermal runaway warning,” Sensors, vol. 24, no. 15, art. 4964, 2024.</a:t>
-            </a:r>
-          </a:p>
-          <a:p>
-            <a:pPr marL="384048" indent="-384048">
-              <a:lnSpc>
-                <a:spcPct val="110000"/>
-              </a:lnSpc>
-              <a:spcAft>
-                <a:spcPts val="2000"/>
-              </a:spcAft>
-              <a:buNone/>
-            </a:pPr>
-            <a:r>
-              <a:rPr sz="1400" b="0" i="0" u="none">
-                <a:solidFill>
-                  <a:srgbClr val="000000"/>
-                </a:solidFill>
-                <a:latin typeface="Times New Roman"/>
-              </a:rPr>
-              <a:t>[4]  </a:t>
-            </a:r>
-            <a:r>
-              <a:rPr sz="1400" b="0" i="0" u="none">
-                <a:solidFill>
-                  <a:srgbClr val="000000"/>
-                </a:solidFill>
-                <a:latin typeface="Times New Roman"/>
-              </a:rPr>
-              <a:t>A. K. M. A. Habib, M. K. Hasan, G. F. Issa, D. Singh, S. Islam and T. M. Ghazal, “Lithium-ion battery management system for electric vehicles: Constraints, challenges and recommendations,” Batteries, vol. 9, no. 3, art. 152, 2023.</a:t>
-            </a:r>
-          </a:p>
-          <a:p>
-            <a:pPr marL="384048" indent="-384048">
-              <a:lnSpc>
-                <a:spcPct val="110000"/>
-              </a:lnSpc>
-              <a:spcAft>
-                <a:spcPts val="2000"/>
-              </a:spcAft>
-              <a:buNone/>
-            </a:pPr>
-            <a:r>
-              <a:rPr sz="1400" b="0" i="0" u="none">
-                <a:solidFill>
-                  <a:srgbClr val="000000"/>
-                </a:solidFill>
-                <a:latin typeface="Times New Roman"/>
-              </a:rPr>
-              <a:t>[5]  </a:t>
-            </a:r>
-            <a:r>
-              <a:rPr sz="1400" b="0" i="0" u="none">
-                <a:solidFill>
-                  <a:srgbClr val="000000"/>
-                </a:solidFill>
-                <a:latin typeface="Times New Roman"/>
-              </a:rPr>
-              <a:t>IS 16046 (Part 2) : 2018 / IEC 62133-2 : 2017, Secondary cells and batteries containing alkaline or other non-acid electrolytes — Part 2: Lithium systems.</a:t>
-            </a:r>
-          </a:p>
-        </p:txBody>
-      </p:sp>
-    </p:spTree>
-  </p:cSld>
-  <p:clrMapOvr>
-    <a:masterClrMapping/>
-  </p:clrMapOvr>
-</p:sld>
-</file>
-
 <file path=ppt/slides/slide8.xml><?xml version="1.0" encoding="utf-8"?>
 <p:sld xmlns:a="http://schemas.openxmlformats.org/drawingml/2006/main" xmlns:p="http://schemas.openxmlformats.org/presentationml/2006/main" xmlns:r="http://schemas.openxmlformats.org/officeDocument/2006/relationships">
   <p:cSld>
@@ -6759,8 +7493,8 @@
         </p:nvSpPr>
         <p:spPr>
           <a:xfrm>
-            <a:off x="929944" y="6355080"/>
-            <a:ext cx="2286000" cy="292608"/>
+            <a:off x="1188720" y="384048"/>
+            <a:ext cx="9814255" cy="548640"/>
           </a:xfrm>
           <a:prstGeom prst="rect">
             <a:avLst/>
@@ -6773,14 +7507,15 @@
           </a:bodyPr>
           <a:lstStyle/>
           <a:p>
-            <a:r>
-              <a:rPr sz="1200" b="0" i="0" u="none">
-                <a:solidFill>
-                  <a:srgbClr val="898989"/>
-                </a:solidFill>
-                <a:latin typeface="Calibri"/>
-              </a:rPr>
-              <a:t>22-07-2026</a:t>
+            <a:pPr algn="ctr"/>
+            <a:r>
+              <a:rPr sz="2400" b="1" i="0" u="sng">
+                <a:solidFill>
+                  <a:srgbClr val="000000"/>
+                </a:solidFill>
+                <a:latin typeface="Times New Roman"/>
+              </a:rPr>
+              <a:t>References</a:t>
             </a:r>
           </a:p>
         </p:txBody>
@@ -6793,8 +7528,8 @@
         </p:nvSpPr>
         <p:spPr>
           <a:xfrm>
-            <a:off x="3931920" y="6355080"/>
-            <a:ext cx="4297680" cy="292608"/>
+            <a:off x="929944" y="6355080"/>
+            <a:ext cx="2286000" cy="292608"/>
           </a:xfrm>
           <a:prstGeom prst="rect">
             <a:avLst/>
@@ -6807,7 +7542,6 @@
           </a:bodyPr>
           <a:lstStyle/>
           <a:p>
-            <a:pPr algn="ctr"/>
             <a:r>
               <a:rPr sz="1200" b="0" i="0" u="none">
                 <a:solidFill>
@@ -6815,7 +7549,7 @@
                 </a:solidFill>
                 <a:latin typeface="Calibri"/>
               </a:rPr>
-              <a:t>Zeroth Review-2026-27</a:t>
+              <a:t>22-07-2026</a:t>
             </a:r>
           </a:p>
         </p:txBody>
@@ -6828,8 +7562,8 @@
         </p:nvSpPr>
         <p:spPr>
           <a:xfrm>
-            <a:off x="10058400" y="6355080"/>
-            <a:ext cx="1204264" cy="292608"/>
+            <a:off x="3931920" y="6355080"/>
+            <a:ext cx="4297680" cy="292608"/>
           </a:xfrm>
           <a:prstGeom prst="rect">
             <a:avLst/>
@@ -6842,6 +7576,41 @@
           </a:bodyPr>
           <a:lstStyle/>
           <a:p>
+            <a:pPr algn="ctr"/>
+            <a:r>
+              <a:rPr sz="1200" b="0" i="0" u="none">
+                <a:solidFill>
+                  <a:srgbClr val="898989"/>
+                </a:solidFill>
+                <a:latin typeface="Calibri"/>
+              </a:rPr>
+              <a:t>Zeroth Review-2026-27</a:t>
+            </a:r>
+          </a:p>
+        </p:txBody>
+      </p:sp>
+      <p:sp>
+        <p:nvSpPr>
+          <p:cNvPr id="6" name="TextBox 5"/>
+          <p:cNvSpPr txBox="1"/>
+          <p:nvPr/>
+        </p:nvSpPr>
+        <p:spPr>
+          <a:xfrm>
+            <a:off x="10058400" y="6355080"/>
+            <a:ext cx="1204264" cy="292608"/>
+          </a:xfrm>
+          <a:prstGeom prst="rect">
+            <a:avLst/>
+          </a:prstGeom>
+          <a:noFill/>
+        </p:spPr>
+        <p:txBody>
+          <a:bodyPr wrap="square" lIns="0" rIns="0" tIns="0" bIns="0">
+            <a:noAutofit/>
+          </a:bodyPr>
+          <a:lstStyle/>
+          <a:p>
             <a:pPr algn="r"/>
             <a:r>
               <a:rPr sz="1200" b="0" i="0" u="none">
@@ -6851,6 +7620,320 @@
                 <a:latin typeface="Calibri"/>
               </a:rPr>
               <a:t>8</a:t>
+            </a:r>
+          </a:p>
+        </p:txBody>
+      </p:sp>
+      <p:sp>
+        <p:nvSpPr>
+          <p:cNvPr id="7" name="TextBox 6"/>
+          <p:cNvSpPr txBox="1"/>
+          <p:nvPr/>
+        </p:nvSpPr>
+        <p:spPr>
+          <a:xfrm>
+            <a:off x="1168603" y="1389888"/>
+            <a:ext cx="10195560" cy="4754879"/>
+          </a:xfrm>
+          <a:prstGeom prst="rect">
+            <a:avLst/>
+          </a:prstGeom>
+          <a:noFill/>
+        </p:spPr>
+        <p:txBody>
+          <a:bodyPr wrap="square" lIns="0" rIns="0" tIns="0" bIns="0">
+            <a:noAutofit/>
+          </a:bodyPr>
+          <a:lstStyle/>
+          <a:p>
+            <a:pPr marL="384048" indent="-384048">
+              <a:lnSpc>
+                <a:spcPct val="110000"/>
+              </a:lnSpc>
+              <a:spcAft>
+                <a:spcPts val="2000"/>
+              </a:spcAft>
+              <a:buNone/>
+            </a:pPr>
+            <a:r>
+              <a:rPr sz="1400" b="0" i="0" u="none">
+                <a:solidFill>
+                  <a:srgbClr val="000000"/>
+                </a:solidFill>
+                <a:latin typeface="Times New Roman"/>
+              </a:rPr>
+              <a:t>[1]  </a:t>
+            </a:r>
+            <a:r>
+              <a:rPr sz="1400" b="0" i="0" u="none">
+                <a:solidFill>
+                  <a:srgbClr val="000000"/>
+                </a:solidFill>
+                <a:latin typeface="Times New Roman"/>
+              </a:rPr>
+              <a:t>X. Feng, M. Ouyang, X. Liu, L. Lu, Y. Xia and X. He, “Thermal runaway mechanism of lithium ion battery for electric vehicles: A review,” Energy Storage Materials, vol. 10, pp. 246–267, 2018.</a:t>
+            </a:r>
+          </a:p>
+          <a:p>
+            <a:pPr marL="384048" indent="-384048">
+              <a:lnSpc>
+                <a:spcPct val="110000"/>
+              </a:lnSpc>
+              <a:spcAft>
+                <a:spcPts val="2000"/>
+              </a:spcAft>
+              <a:buNone/>
+            </a:pPr>
+            <a:r>
+              <a:rPr sz="1400" b="0" i="0" u="none">
+                <a:solidFill>
+                  <a:srgbClr val="000000"/>
+                </a:solidFill>
+                <a:latin typeface="Times New Roman"/>
+              </a:rPr>
+              <a:t>[2]  </a:t>
+            </a:r>
+            <a:r>
+              <a:rPr sz="1400" b="0" i="0" u="none">
+                <a:solidFill>
+                  <a:srgbClr val="000000"/>
+                </a:solidFill>
+                <a:latin typeface="Times New Roman"/>
+              </a:rPr>
+              <a:t>X. Zhang, S. Chen, J. Zhu et al., “A critical review of thermal runaway prediction and early-warning methods for lithium-ion batteries,” Energy Material Advances, vol. 4, art. 0008, 2023.</a:t>
+            </a:r>
+          </a:p>
+          <a:p>
+            <a:pPr marL="384048" indent="-384048">
+              <a:lnSpc>
+                <a:spcPct val="110000"/>
+              </a:lnSpc>
+              <a:spcAft>
+                <a:spcPts val="2000"/>
+              </a:spcAft>
+              <a:buNone/>
+            </a:pPr>
+            <a:r>
+              <a:rPr sz="1400" b="0" i="0" u="none">
+                <a:solidFill>
+                  <a:srgbClr val="000000"/>
+                </a:solidFill>
+                <a:latin typeface="Times New Roman"/>
+              </a:rPr>
+              <a:t>[3]  </a:t>
+            </a:r>
+            <a:r>
+              <a:rPr sz="1400" b="0" i="0" u="none">
+                <a:solidFill>
+                  <a:srgbClr val="000000"/>
+                </a:solidFill>
+                <a:latin typeface="Times New Roman"/>
+              </a:rPr>
+              <a:t>Q. Chen, Y. He, N. Fang and G. Yu, “A combined data-driven and model-based algorithm for accurate battery thermal runaway warning,” Sensors, vol. 24, no. 15, art. 4964, 2024.</a:t>
+            </a:r>
+          </a:p>
+          <a:p>
+            <a:pPr marL="384048" indent="-384048">
+              <a:lnSpc>
+                <a:spcPct val="110000"/>
+              </a:lnSpc>
+              <a:spcAft>
+                <a:spcPts val="2000"/>
+              </a:spcAft>
+              <a:buNone/>
+            </a:pPr>
+            <a:r>
+              <a:rPr sz="1400" b="0" i="0" u="none">
+                <a:solidFill>
+                  <a:srgbClr val="000000"/>
+                </a:solidFill>
+                <a:latin typeface="Times New Roman"/>
+              </a:rPr>
+              <a:t>[4]  </a:t>
+            </a:r>
+            <a:r>
+              <a:rPr sz="1400" b="0" i="0" u="none">
+                <a:solidFill>
+                  <a:srgbClr val="000000"/>
+                </a:solidFill>
+                <a:latin typeface="Times New Roman"/>
+              </a:rPr>
+              <a:t>A. K. M. A. Habib, M. K. Hasan, G. F. Issa, D. Singh, S. Islam and T. M. Ghazal, “Lithium-ion battery management system for electric vehicles: Constraints, challenges and recommendations,” Batteries, vol. 9, no. 3, art. 152, 2023.</a:t>
+            </a:r>
+          </a:p>
+          <a:p>
+            <a:pPr marL="384048" indent="-384048">
+              <a:lnSpc>
+                <a:spcPct val="110000"/>
+              </a:lnSpc>
+              <a:spcAft>
+                <a:spcPts val="2000"/>
+              </a:spcAft>
+              <a:buNone/>
+            </a:pPr>
+            <a:r>
+              <a:rPr sz="1400" b="0" i="0" u="none">
+                <a:solidFill>
+                  <a:srgbClr val="000000"/>
+                </a:solidFill>
+                <a:latin typeface="Times New Roman"/>
+              </a:rPr>
+              <a:t>[5]  </a:t>
+            </a:r>
+            <a:r>
+              <a:rPr sz="1400" b="0" i="0" u="none">
+                <a:solidFill>
+                  <a:srgbClr val="000000"/>
+                </a:solidFill>
+                <a:latin typeface="Times New Roman"/>
+              </a:rPr>
+              <a:t>IS 16046 (Part 2) : 2018 / IEC 62133-2 : 2017, Secondary cells and batteries containing alkaline or other non-acid electrolytes — Part 2: Lithium systems.</a:t>
+            </a:r>
+          </a:p>
+        </p:txBody>
+      </p:sp>
+    </p:spTree>
+  </p:cSld>
+  <p:clrMapOvr>
+    <a:masterClrMapping/>
+  </p:clrMapOvr>
+</p:sld>
+</file>
+
+<file path=ppt/slides/slide9.xml><?xml version="1.0" encoding="utf-8"?>
+<p:sld xmlns:a="http://schemas.openxmlformats.org/drawingml/2006/main" xmlns:p="http://schemas.openxmlformats.org/presentationml/2006/main" xmlns:r="http://schemas.openxmlformats.org/officeDocument/2006/relationships">
+  <p:cSld>
+    <p:spTree>
+      <p:nvGrpSpPr>
+        <p:cNvPr id="1" name=""/>
+        <p:cNvGrpSpPr/>
+        <p:nvPr/>
+      </p:nvGrpSpPr>
+      <p:grpSpPr/>
+      <p:pic>
+        <p:nvPicPr>
+          <p:cNvPr id="2" name="Picture 1" descr="logo.png"/>
+          <p:cNvPicPr>
+            <a:picLocks noChangeAspect="1"/>
+          </p:cNvPicPr>
+          <p:nvPr/>
+        </p:nvPicPr>
+        <p:blipFill>
+          <a:blip r:embed="rId2"/>
+          <a:stretch>
+            <a:fillRect/>
+          </a:stretch>
+        </p:blipFill>
+        <p:spPr>
+          <a:xfrm>
+            <a:off x="286207" y="109728"/>
+            <a:ext cx="646480" cy="950976"/>
+          </a:xfrm>
+          <a:prstGeom prst="rect">
+            <a:avLst/>
+          </a:prstGeom>
+        </p:spPr>
+      </p:pic>
+      <p:sp>
+        <p:nvSpPr>
+          <p:cNvPr id="3" name="TextBox 2"/>
+          <p:cNvSpPr txBox="1"/>
+          <p:nvPr/>
+        </p:nvSpPr>
+        <p:spPr>
+          <a:xfrm>
+            <a:off x="929944" y="6355080"/>
+            <a:ext cx="2286000" cy="292608"/>
+          </a:xfrm>
+          <a:prstGeom prst="rect">
+            <a:avLst/>
+          </a:prstGeom>
+          <a:noFill/>
+        </p:spPr>
+        <p:txBody>
+          <a:bodyPr wrap="square" lIns="0" rIns="0" tIns="0" bIns="0">
+            <a:noAutofit/>
+          </a:bodyPr>
+          <a:lstStyle/>
+          <a:p>
+            <a:r>
+              <a:rPr sz="1200" b="0" i="0" u="none">
+                <a:solidFill>
+                  <a:srgbClr val="898989"/>
+                </a:solidFill>
+                <a:latin typeface="Calibri"/>
+              </a:rPr>
+              <a:t>22-07-2026</a:t>
+            </a:r>
+          </a:p>
+        </p:txBody>
+      </p:sp>
+      <p:sp>
+        <p:nvSpPr>
+          <p:cNvPr id="4" name="TextBox 3"/>
+          <p:cNvSpPr txBox="1"/>
+          <p:nvPr/>
+        </p:nvSpPr>
+        <p:spPr>
+          <a:xfrm>
+            <a:off x="3931920" y="6355080"/>
+            <a:ext cx="4297680" cy="292608"/>
+          </a:xfrm>
+          <a:prstGeom prst="rect">
+            <a:avLst/>
+          </a:prstGeom>
+          <a:noFill/>
+        </p:spPr>
+        <p:txBody>
+          <a:bodyPr wrap="square" lIns="0" rIns="0" tIns="0" bIns="0">
+            <a:noAutofit/>
+          </a:bodyPr>
+          <a:lstStyle/>
+          <a:p>
+            <a:pPr algn="ctr"/>
+            <a:r>
+              <a:rPr sz="1200" b="0" i="0" u="none">
+                <a:solidFill>
+                  <a:srgbClr val="898989"/>
+                </a:solidFill>
+                <a:latin typeface="Calibri"/>
+              </a:rPr>
+              <a:t>Zeroth Review-2026-27</a:t>
+            </a:r>
+          </a:p>
+        </p:txBody>
+      </p:sp>
+      <p:sp>
+        <p:nvSpPr>
+          <p:cNvPr id="5" name="TextBox 4"/>
+          <p:cNvSpPr txBox="1"/>
+          <p:nvPr/>
+        </p:nvSpPr>
+        <p:spPr>
+          <a:xfrm>
+            <a:off x="10058400" y="6355080"/>
+            <a:ext cx="1204264" cy="292608"/>
+          </a:xfrm>
+          <a:prstGeom prst="rect">
+            <a:avLst/>
+          </a:prstGeom>
+          <a:noFill/>
+        </p:spPr>
+        <p:txBody>
+          <a:bodyPr wrap="square" lIns="0" rIns="0" tIns="0" bIns="0">
+            <a:noAutofit/>
+          </a:bodyPr>
+          <a:lstStyle/>
+          <a:p>
+            <a:pPr algn="r"/>
+            <a:r>
+              <a:rPr sz="1200" b="0" i="0" u="none">
+                <a:solidFill>
+                  <a:srgbClr val="898989"/>
+                </a:solidFill>
+                <a:latin typeface="Calibri"/>
+              </a:rPr>
+              <a:t>9</a:t>
             </a:r>
           </a:p>
         </p:txBody>

</xml_diff>

<commit_message>
docs: add a components slide to the zeroth review
A plain list of the main parts, how many of each, and what each one is for.
It sits between the implementation outline and the tools, so the deck reads
as how it works, what it is made of, then what it is built with.

Kept at the level a zeroth review needs: no part numbers, no specifications
and no costs. The priced bill of materials stays in the first review.
</commit_message>
<xml_diff>
--- a/docs/reviews/zeroth-review/Predictive_BMS_Zeroth_Review.pptx
+++ b/docs/reviews/zeroth-review/Predictive_BMS_Zeroth_Review.pptx
@@ -14,6 +14,7 @@
     <p:sldId id="262" r:id="rId14"/>
     <p:sldId id="263" r:id="rId15"/>
     <p:sldId id="264" r:id="rId16"/>
+    <p:sldId id="265" r:id="rId17"/>
   </p:sldIdLst>
   <p:sldSz cx="12191695" cy="6858000" type="screen4x3"/>
   <p:notesSz cx="6858000" cy="9144000"/>
@@ -555,6 +556,81 @@
 </p:notes>
 </file>
 
+<file path=ppt/notesSlides/notesSlide10.xml><?xml version="1.0" encoding="utf-8"?>
+<p:notes xmlns:a="http://schemas.openxmlformats.org/drawingml/2006/main" xmlns:p="http://schemas.openxmlformats.org/presentationml/2006/main" xmlns:r="http://schemas.openxmlformats.org/officeDocument/2006/relationships">
+  <p:cSld>
+    <p:spTree>
+      <p:nvGrpSpPr>
+        <p:cNvPr id="1" name=""/>
+        <p:cNvGrpSpPr/>
+        <p:nvPr/>
+      </p:nvGrpSpPr>
+      <p:grpSpPr>
+        <a:xfrm>
+          <a:off x="0" y="0"/>
+          <a:ext cx="0" cy="0"/>
+          <a:chOff x="0" y="0"/>
+          <a:chExt cx="0" cy="0"/>
+        </a:xfrm>
+      </p:grpSpPr>
+      <p:sp>
+        <p:nvSpPr>
+          <p:cNvPr id="2" name="Slide Image Placeholder 1"/>
+          <p:cNvSpPr>
+            <a:spLocks noGrp="1"/>
+          </p:cNvSpPr>
+          <p:nvPr>
+            <p:ph type="sldImg" idx="2"/>
+          </p:nvPr>
+        </p:nvSpPr>
+        <p:spPr/>
+      </p:sp>
+      <p:sp>
+        <p:nvSpPr>
+          <p:cNvPr id="3" name="Notes Placeholder 2"/>
+          <p:cNvSpPr>
+            <a:spLocks noGrp="1"/>
+          </p:cNvSpPr>
+          <p:nvPr>
+            <p:ph type="body" idx="3" sz="quarter"/>
+          </p:nvPr>
+        </p:nvSpPr>
+        <p:spPr/>
+        <p:txBody>
+          <a:bodyPr/>
+          <a:lstStyle/>
+          <a:p>
+            <a:r>
+              <a:t>That is the end of my presentation. Thank you for listening. I am happy to take</a:t>
+            </a:r>
+          </a:p>
+          <a:p>
+            <a:r>
+              <a:t>questions on the circuit, the choice of threshold, or the schedule.</a:t>
+            </a:r>
+          </a:p>
+        </p:txBody>
+      </p:sp>
+      <p:sp>
+        <p:nvSpPr>
+          <p:cNvPr id="4" name="Slide Number Placeholder 3"/>
+          <p:cNvSpPr>
+            <a:spLocks noGrp="1"/>
+          </p:cNvSpPr>
+          <p:nvPr>
+            <p:ph type="sldNum" idx="5" sz="quarter"/>
+          </p:nvPr>
+        </p:nvSpPr>
+        <p:spPr/>
+      </p:sp>
+    </p:spTree>
+  </p:cSld>
+  <p:clrMapOvr>
+    <a:masterClrMapping/>
+  </p:clrMapOvr>
+</p:notes>
+</file>
+
 <file path=ppt/notesSlides/notesSlide2.xml><?xml version="1.0" encoding="utf-8"?>
 <p:notes xmlns:a="http://schemas.openxmlformats.org/drawingml/2006/main" xmlns:p="http://schemas.openxmlformats.org/presentationml/2006/main" xmlns:r="http://schemas.openxmlformats.org/officeDocument/2006/relationships">
   <p:cSld>
@@ -965,37 +1041,42 @@
           <a:lstStyle/>
           <a:p>
             <a:r>
-              <a:t>This project is not one or the other. There is a circuit to build and there is</a:t>
-            </a:r>
-          </a:p>
-          <a:p>
-            <a:r>
-              <a:t>firmware to write for it, and neither works without the other. The hardware side</a:t>
-            </a:r>
-          </a:p>
-          <a:p>
-            <a:r>
-              <a:t>is the pack, the sensing, the protection MOSFETs and the enclosure. The software</a:t>
-            </a:r>
-          </a:p>
-          <a:p>
-            <a:r>
-              <a:t>side is the firmware on the ESP32 and the dashboard page. The firmware is</a:t>
-            </a:r>
-          </a:p>
-          <a:p>
-            <a:r>
-              <a:t>written in C++ on ESP-IDF, which is the framework Espressif supply for the</a:t>
-            </a:r>
-          </a:p>
-          <a:p>
-            <a:r>
-              <a:t>ESP32, and it uses FreeRTOS underneath to keep the sensor, safety and telemetry</a:t>
-            </a:r>
-          </a:p>
-          <a:p>
-            <a:r>
-              <a:t>work in separate tasks.</a:t>
+              <a:t>These are the main parts. The pack is four 18650 cells in series. Around it sit</a:t>
+            </a:r>
+          </a:p>
+          <a:p>
+            <a:r>
+              <a:t>the things that watch it: four thermistors for temperature, a resistor divider</a:t>
+            </a:r>
+          </a:p>
+          <a:p>
+            <a:r>
+              <a:t>on each cell for voltage, and one current sensor for the whole pack. The</a:t>
+            </a:r>
+          </a:p>
+          <a:p>
+            <a:r>
+              <a:t>multiplexer is there because the ESP32 does not have enough analogue pins for</a:t>
+            </a:r>
+          </a:p>
+          <a:p>
+            <a:r>
+              <a:t>four thermistors as well as four cell taps, so one pin reads all four in turn.</a:t>
+            </a:r>
+          </a:p>
+          <a:p>
+            <a:r>
+              <a:t>The MOSFETs are the switches that actually stop the current. The fuse is there</a:t>
+            </a:r>
+          </a:p>
+          <a:p>
+            <a:r>
+              <a:t>in case everything else fails. I have priced all of these and the full list with</a:t>
+            </a:r>
+          </a:p>
+          <a:p>
+            <a:r>
+              <a:t>costs will come in the next review.</a:t>
             </a:r>
           </a:p>
         </p:txBody>
@@ -1065,32 +1146,37 @@
           <a:lstStyle/>
           <a:p>
             <a:r>
-              <a:t>These five sources shaped the project. The first explains the physics: the heat</a:t>
-            </a:r>
-          </a:p>
-          <a:p>
-            <a:r>
-              <a:t>inside a cell feeds more reaction, which makes more heat, so the temperature</a:t>
-            </a:r>
-          </a:p>
-          <a:p>
-            <a:r>
-              <a:t>curve bends upward sharply. The second and fourth show that early warning is a</a:t>
-            </a:r>
-          </a:p>
-          <a:p>
-            <a:r>
-              <a:t>known open problem. The third is the closest work to mine and is where the one</a:t>
-            </a:r>
-          </a:p>
-          <a:p>
-            <a:r>
-              <a:t>degree per second figure comes from. The last is the standard my design is aimed</a:t>
-            </a:r>
-          </a:p>
-          <a:p>
-            <a:r>
-              <a:t>at, although I am not claiming certification.</a:t>
+              <a:t>This project is not one or the other. There is a circuit to build and there is</a:t>
+            </a:r>
+          </a:p>
+          <a:p>
+            <a:r>
+              <a:t>firmware to write for it, and neither works without the other. The hardware side</a:t>
+            </a:r>
+          </a:p>
+          <a:p>
+            <a:r>
+              <a:t>is the pack, the sensing, the protection MOSFETs and the enclosure. The software</a:t>
+            </a:r>
+          </a:p>
+          <a:p>
+            <a:r>
+              <a:t>side is the firmware on the ESP32 and the dashboard page. The firmware is</a:t>
+            </a:r>
+          </a:p>
+          <a:p>
+            <a:r>
+              <a:t>written in C++ on ESP-IDF, which is the framework Espressif supply for the</a:t>
+            </a:r>
+          </a:p>
+          <a:p>
+            <a:r>
+              <a:t>ESP32, and it uses FreeRTOS underneath to keep the sensor, safety and telemetry</a:t>
+            </a:r>
+          </a:p>
+          <a:p>
+            <a:r>
+              <a:t>work in separate tasks.</a:t>
             </a:r>
           </a:p>
         </p:txBody>
@@ -1160,22 +1246,32 @@
           <a:lstStyle/>
           <a:p>
             <a:r>
-              <a:t>These are the five sources, numbered in the same order as the survey table on</a:t>
-            </a:r>
-          </a:p>
-          <a:p>
-            <a:r>
-              <a:t>the previous slide. The first four are papers and reviews. The fifth is the</a:t>
-            </a:r>
-          </a:p>
-          <a:p>
-            <a:r>
-              <a:t>Indian standard for sealed lithium cells, which sets out the abuse tests a pack</a:t>
-            </a:r>
-          </a:p>
-          <a:p>
-            <a:r>
-              <a:t>of this kind is expected to survive.</a:t>
+              <a:t>These five sources shaped the project. The first explains the physics: the heat</a:t>
+            </a:r>
+          </a:p>
+          <a:p>
+            <a:r>
+              <a:t>inside a cell feeds more reaction, which makes more heat, so the temperature</a:t>
+            </a:r>
+          </a:p>
+          <a:p>
+            <a:r>
+              <a:t>curve bends upward sharply. The second and fourth show that early warning is a</a:t>
+            </a:r>
+          </a:p>
+          <a:p>
+            <a:r>
+              <a:t>known open problem. The third is the closest work to mine and is where the one</a:t>
+            </a:r>
+          </a:p>
+          <a:p>
+            <a:r>
+              <a:t>degree per second figure comes from. The last is the standard my design is aimed</a:t>
+            </a:r>
+          </a:p>
+          <a:p>
+            <a:r>
+              <a:t>at, although I am not claiming certification.</a:t>
             </a:r>
           </a:p>
         </p:txBody>
@@ -1245,12 +1341,22 @@
           <a:lstStyle/>
           <a:p>
             <a:r>
-              <a:t>That is the end of my presentation. Thank you for listening. I am happy to take</a:t>
-            </a:r>
-          </a:p>
-          <a:p>
-            <a:r>
-              <a:t>questions on the circuit, the choice of threshold, or the schedule.</a:t>
+              <a:t>These are the five sources, numbered in the same order as the survey table on</a:t>
+            </a:r>
+          </a:p>
+          <a:p>
+            <a:r>
+              <a:t>the previous slide. The first four are papers and reviews. The fifth is the</a:t>
+            </a:r>
+          </a:p>
+          <a:p>
+            <a:r>
+              <a:t>Indian standard for sealed lithium cells, which sets out the abuse tests a pack</a:t>
+            </a:r>
+          </a:p>
+          <a:p>
+            <a:r>
+              <a:t>of this kind is expected to survive.</a:t>
             </a:r>
           </a:p>
         </p:txBody>
@@ -4642,6 +4748,211 @@
 </p:sld>
 </file>
 
+<file path=ppt/slides/slide10.xml><?xml version="1.0" encoding="utf-8"?>
+<p:sld xmlns:a="http://schemas.openxmlformats.org/drawingml/2006/main" xmlns:p="http://schemas.openxmlformats.org/presentationml/2006/main" xmlns:r="http://schemas.openxmlformats.org/officeDocument/2006/relationships">
+  <p:cSld>
+    <p:spTree>
+      <p:nvGrpSpPr>
+        <p:cNvPr id="1" name=""/>
+        <p:cNvGrpSpPr/>
+        <p:nvPr/>
+      </p:nvGrpSpPr>
+      <p:grpSpPr/>
+      <p:pic>
+        <p:nvPicPr>
+          <p:cNvPr id="2" name="Picture 1" descr="logo.png"/>
+          <p:cNvPicPr>
+            <a:picLocks noChangeAspect="1"/>
+          </p:cNvPicPr>
+          <p:nvPr/>
+        </p:nvPicPr>
+        <p:blipFill>
+          <a:blip r:embed="rId2"/>
+          <a:stretch>
+            <a:fillRect/>
+          </a:stretch>
+        </p:blipFill>
+        <p:spPr>
+          <a:xfrm>
+            <a:off x="286207" y="109728"/>
+            <a:ext cx="646480" cy="950976"/>
+          </a:xfrm>
+          <a:prstGeom prst="rect">
+            <a:avLst/>
+          </a:prstGeom>
+        </p:spPr>
+      </p:pic>
+      <p:sp>
+        <p:nvSpPr>
+          <p:cNvPr id="3" name="TextBox 2"/>
+          <p:cNvSpPr txBox="1"/>
+          <p:nvPr/>
+        </p:nvSpPr>
+        <p:spPr>
+          <a:xfrm>
+            <a:off x="929944" y="6355080"/>
+            <a:ext cx="2286000" cy="292608"/>
+          </a:xfrm>
+          <a:prstGeom prst="rect">
+            <a:avLst/>
+          </a:prstGeom>
+          <a:noFill/>
+        </p:spPr>
+        <p:txBody>
+          <a:bodyPr wrap="square" lIns="0" rIns="0" tIns="0" bIns="0">
+            <a:noAutofit/>
+          </a:bodyPr>
+          <a:lstStyle/>
+          <a:p>
+            <a:r>
+              <a:rPr sz="1200" b="0" i="0" u="none">
+                <a:solidFill>
+                  <a:srgbClr val="898989"/>
+                </a:solidFill>
+                <a:latin typeface="Calibri"/>
+              </a:rPr>
+              <a:t>22-07-2026</a:t>
+            </a:r>
+          </a:p>
+        </p:txBody>
+      </p:sp>
+      <p:sp>
+        <p:nvSpPr>
+          <p:cNvPr id="4" name="TextBox 3"/>
+          <p:cNvSpPr txBox="1"/>
+          <p:nvPr/>
+        </p:nvSpPr>
+        <p:spPr>
+          <a:xfrm>
+            <a:off x="3931920" y="6355080"/>
+            <a:ext cx="4297680" cy="292608"/>
+          </a:xfrm>
+          <a:prstGeom prst="rect">
+            <a:avLst/>
+          </a:prstGeom>
+          <a:noFill/>
+        </p:spPr>
+        <p:txBody>
+          <a:bodyPr wrap="square" lIns="0" rIns="0" tIns="0" bIns="0">
+            <a:noAutofit/>
+          </a:bodyPr>
+          <a:lstStyle/>
+          <a:p>
+            <a:pPr algn="ctr"/>
+            <a:r>
+              <a:rPr sz="1200" b="0" i="0" u="none">
+                <a:solidFill>
+                  <a:srgbClr val="898989"/>
+                </a:solidFill>
+                <a:latin typeface="Calibri"/>
+              </a:rPr>
+              <a:t>Zeroth Review-2026-27</a:t>
+            </a:r>
+          </a:p>
+        </p:txBody>
+      </p:sp>
+      <p:sp>
+        <p:nvSpPr>
+          <p:cNvPr id="5" name="TextBox 4"/>
+          <p:cNvSpPr txBox="1"/>
+          <p:nvPr/>
+        </p:nvSpPr>
+        <p:spPr>
+          <a:xfrm>
+            <a:off x="10058400" y="6355080"/>
+            <a:ext cx="1204264" cy="292608"/>
+          </a:xfrm>
+          <a:prstGeom prst="rect">
+            <a:avLst/>
+          </a:prstGeom>
+          <a:noFill/>
+        </p:spPr>
+        <p:txBody>
+          <a:bodyPr wrap="square" lIns="0" rIns="0" tIns="0" bIns="0">
+            <a:noAutofit/>
+          </a:bodyPr>
+          <a:lstStyle/>
+          <a:p>
+            <a:pPr algn="r"/>
+            <a:r>
+              <a:rPr sz="1200" b="0" i="0" u="none">
+                <a:solidFill>
+                  <a:srgbClr val="898989"/>
+                </a:solidFill>
+                <a:latin typeface="Calibri"/>
+              </a:rPr>
+              <a:t>10</a:t>
+            </a:r>
+          </a:p>
+        </p:txBody>
+      </p:sp>
+      <p:sp>
+        <p:nvSpPr>
+          <p:cNvPr id="6" name="TextBox 5"/>
+          <p:cNvSpPr txBox="1"/>
+          <p:nvPr/>
+        </p:nvSpPr>
+        <p:spPr>
+          <a:xfrm>
+            <a:off x="1188720" y="2606040"/>
+            <a:ext cx="9814255" cy="1463040"/>
+          </a:xfrm>
+          <a:prstGeom prst="rect">
+            <a:avLst/>
+          </a:prstGeom>
+          <a:noFill/>
+        </p:spPr>
+        <p:txBody>
+          <a:bodyPr wrap="square" lIns="0" rIns="0" tIns="0" bIns="0">
+            <a:noAutofit/>
+          </a:bodyPr>
+          <a:lstStyle/>
+          <a:p>
+            <a:pPr algn="ctr"/>
+            <a:r>
+              <a:rPr sz="4000" b="1" i="0" u="none">
+                <a:solidFill>
+                  <a:srgbClr val="000000"/>
+                </a:solidFill>
+                <a:latin typeface="Times New Roman"/>
+              </a:rPr>
+              <a:t>Thank You</a:t>
+            </a:r>
+          </a:p>
+          <a:p>
+            <a:pPr algn="ctr"/>
+            <a:r>
+              <a:rPr sz="1800" b="0" i="0" u="none">
+                <a:solidFill>
+                  <a:srgbClr val="000000"/>
+                </a:solidFill>
+                <a:latin typeface="Times New Roman"/>
+              </a:rPr>
+              <a:t/>
+            </a:r>
+          </a:p>
+          <a:p>
+            <a:pPr algn="ctr"/>
+            <a:r>
+              <a:rPr sz="2000" b="0" i="0" u="none">
+                <a:solidFill>
+                  <a:srgbClr val="002060"/>
+                </a:solidFill>
+                <a:latin typeface="Times New Roman"/>
+              </a:rPr>
+              <a:t>Questions are welcome</a:t>
+            </a:r>
+          </a:p>
+        </p:txBody>
+      </p:sp>
+    </p:spTree>
+  </p:cSld>
+  <p:clrMapOvr>
+    <a:masterClrMapping/>
+  </p:clrMapOvr>
+</p:sld>
+</file>
+
 <file path=ppt/slides/slide2.xml><?xml version="1.0" encoding="utf-8"?>
 <p:sld xmlns:a="http://schemas.openxmlformats.org/drawingml/2006/main" xmlns:p="http://schemas.openxmlformats.org/presentationml/2006/main" xmlns:r="http://schemas.openxmlformats.org/officeDocument/2006/relationships">
   <p:cSld>
@@ -4978,7 +5289,7 @@
                 </a:solidFill>
                 <a:latin typeface="Times New Roman"/>
               </a:rPr>
-              <a:t>Implementation and Tools</a:t>
+              <a:t>Components</a:t>
             </a:r>
           </a:p>
           <a:p>
@@ -5007,7 +5318,7 @@
                 </a:solidFill>
                 <a:latin typeface="Times New Roman"/>
               </a:rPr>
-              <a:t>Literature Survey</a:t>
+              <a:t>Implementation and Tools</a:t>
             </a:r>
           </a:p>
           <a:p>
@@ -5028,6 +5339,35 @@
                 <a:latin typeface="Times New Roman"/>
               </a:rPr>
               <a:t>7.  </a:t>
+            </a:r>
+            <a:r>
+              <a:rPr sz="1800" b="0" i="0" u="none">
+                <a:solidFill>
+                  <a:srgbClr val="000000"/>
+                </a:solidFill>
+                <a:latin typeface="Times New Roman"/>
+              </a:rPr>
+              <a:t>Literature Survey</a:t>
+            </a:r>
+          </a:p>
+          <a:p>
+            <a:pPr marL="384048" indent="-384048">
+              <a:lnSpc>
+                <a:spcPct val="110000"/>
+              </a:lnSpc>
+              <a:spcAft>
+                <a:spcPts val="1300"/>
+              </a:spcAft>
+              <a:buNone/>
+            </a:pPr>
+            <a:r>
+              <a:rPr sz="1800" b="0" i="0" u="none">
+                <a:solidFill>
+                  <a:srgbClr val="000000"/>
+                </a:solidFill>
+                <a:latin typeface="Times New Roman"/>
+              </a:rPr>
+              <a:t>8.  </a:t>
             </a:r>
             <a:r>
               <a:rPr sz="1800" b="0" i="0" u="none">
@@ -6067,7 +6407,7 @@
                 </a:solidFill>
                 <a:latin typeface="Times New Roman"/>
               </a:rPr>
-              <a:t>Implementation and Tools</a:t>
+              <a:t>Components</a:t>
             </a:r>
           </a:p>
         </p:txBody>
@@ -6172,6 +6512,995 @@
                 <a:latin typeface="Calibri"/>
               </a:rPr>
               <a:t>6</a:t>
+            </a:r>
+          </a:p>
+        </p:txBody>
+      </p:sp>
+      <p:graphicFrame>
+        <p:nvGraphicFramePr>
+          <p:cNvPr id="7" name="Table 6"/>
+          <p:cNvGraphicFramePr>
+            <a:graphicFrameLocks noGrp="1"/>
+          </p:cNvGraphicFramePr>
+          <p:nvPr/>
+        </p:nvGraphicFramePr>
+        <p:xfrm>
+          <a:off x="998067" y="1389888"/>
+          <a:ext cx="10195560" cy="4425696"/>
+        </p:xfrm>
+        <a:graphic>
+          <a:graphicData uri="http://schemas.openxmlformats.org/drawingml/2006/table">
+            <a:tbl>
+              <a:tblPr firstRow="1">
+                <a:tableStyleId>{5C22544A-7EE6-4342-B048-85BDC9FD1C3A}</a:tableStyleId>
+              </a:tblPr>
+              <a:tblGrid>
+                <a:gridCol w="3200400"/>
+                <a:gridCol w="1371600"/>
+                <a:gridCol w="5623560"/>
+              </a:tblGrid>
+              <a:tr h="402336">
+                <a:tc>
+                  <a:txBody>
+                    <a:bodyPr/>
+                    <a:lstStyle/>
+                    <a:p>
+                      <a:pPr algn="ctr"/>
+                      <a:r>
+                        <a:rPr sz="1500" b="1" i="0" u="none">
+                          <a:solidFill>
+                            <a:srgbClr val="FFFFFF"/>
+                          </a:solidFill>
+                          <a:latin typeface="Times New Roman"/>
+                        </a:rPr>
+                        <a:t>Component</a:t>
+                      </a:r>
+                    </a:p>
+                  </a:txBody>
+                  <a:tcPr anchor="ctr" marL="64008" marR="64008">
+                    <a:solidFill>
+                      <a:srgbClr val="002060"/>
+                    </a:solidFill>
+                  </a:tcPr>
+                </a:tc>
+                <a:tc>
+                  <a:txBody>
+                    <a:bodyPr/>
+                    <a:lstStyle/>
+                    <a:p>
+                      <a:pPr algn="ctr"/>
+                      <a:r>
+                        <a:rPr sz="1500" b="1" i="0" u="none">
+                          <a:solidFill>
+                            <a:srgbClr val="FFFFFF"/>
+                          </a:solidFill>
+                          <a:latin typeface="Times New Roman"/>
+                        </a:rPr>
+                        <a:t>How many</a:t>
+                      </a:r>
+                    </a:p>
+                  </a:txBody>
+                  <a:tcPr anchor="ctr" marL="64008" marR="64008">
+                    <a:solidFill>
+                      <a:srgbClr val="002060"/>
+                    </a:solidFill>
+                  </a:tcPr>
+                </a:tc>
+                <a:tc>
+                  <a:txBody>
+                    <a:bodyPr/>
+                    <a:lstStyle/>
+                    <a:p>
+                      <a:pPr algn="ctr"/>
+                      <a:r>
+                        <a:rPr sz="1500" b="1" i="0" u="none">
+                          <a:solidFill>
+                            <a:srgbClr val="FFFFFF"/>
+                          </a:solidFill>
+                          <a:latin typeface="Times New Roman"/>
+                        </a:rPr>
+                        <a:t>What it does</a:t>
+                      </a:r>
+                    </a:p>
+                  </a:txBody>
+                  <a:tcPr anchor="ctr" marL="64008" marR="64008">
+                    <a:solidFill>
+                      <a:srgbClr val="002060"/>
+                    </a:solidFill>
+                  </a:tcPr>
+                </a:tc>
+              </a:tr>
+              <a:tr h="402336">
+                <a:tc>
+                  <a:txBody>
+                    <a:bodyPr/>
+                    <a:lstStyle/>
+                    <a:p>
+                      <a:pPr algn="l"/>
+                      <a:r>
+                        <a:rPr sz="1500" b="0" i="0" u="none">
+                          <a:solidFill>
+                            <a:srgbClr val="000000"/>
+                          </a:solidFill>
+                          <a:latin typeface="Times New Roman"/>
+                        </a:rPr>
+                        <a:t>18650 lithium-ion cells</a:t>
+                      </a:r>
+                    </a:p>
+                  </a:txBody>
+                  <a:tcPr anchor="ctr" marL="64008" marR="64008" marT="27432" marB="27432">
+                    <a:solidFill>
+                      <a:srgbClr val="FFFFFF"/>
+                    </a:solidFill>
+                  </a:tcPr>
+                </a:tc>
+                <a:tc>
+                  <a:txBody>
+                    <a:bodyPr/>
+                    <a:lstStyle/>
+                    <a:p>
+                      <a:pPr algn="ctr"/>
+                      <a:r>
+                        <a:rPr sz="1500" b="0" i="0" u="none">
+                          <a:solidFill>
+                            <a:srgbClr val="000000"/>
+                          </a:solidFill>
+                          <a:latin typeface="Times New Roman"/>
+                        </a:rPr>
+                        <a:t>4</a:t>
+                      </a:r>
+                    </a:p>
+                  </a:txBody>
+                  <a:tcPr anchor="ctr" marL="64008" marR="64008" marT="27432" marB="27432">
+                    <a:solidFill>
+                      <a:srgbClr val="FFFFFF"/>
+                    </a:solidFill>
+                  </a:tcPr>
+                </a:tc>
+                <a:tc>
+                  <a:txBody>
+                    <a:bodyPr/>
+                    <a:lstStyle/>
+                    <a:p>
+                      <a:pPr algn="l"/>
+                      <a:r>
+                        <a:rPr sz="1500" b="0" i="0" u="none">
+                          <a:solidFill>
+                            <a:srgbClr val="000000"/>
+                          </a:solidFill>
+                          <a:latin typeface="Times New Roman"/>
+                        </a:rPr>
+                        <a:t>The battery pack the system looks after</a:t>
+                      </a:r>
+                    </a:p>
+                  </a:txBody>
+                  <a:tcPr anchor="ctr" marL="64008" marR="64008" marT="27432" marB="27432">
+                    <a:solidFill>
+                      <a:srgbClr val="FFFFFF"/>
+                    </a:solidFill>
+                  </a:tcPr>
+                </a:tc>
+              </a:tr>
+              <a:tr h="402336">
+                <a:tc>
+                  <a:txBody>
+                    <a:bodyPr/>
+                    <a:lstStyle/>
+                    <a:p>
+                      <a:pPr algn="l"/>
+                      <a:r>
+                        <a:rPr sz="1500" b="0" i="0" u="none">
+                          <a:solidFill>
+                            <a:srgbClr val="000000"/>
+                          </a:solidFill>
+                          <a:latin typeface="Times New Roman"/>
+                        </a:rPr>
+                        <a:t>ESP32 board</a:t>
+                      </a:r>
+                    </a:p>
+                  </a:txBody>
+                  <a:tcPr anchor="ctr" marL="64008" marR="64008" marT="27432" marB="27432">
+                    <a:solidFill>
+                      <a:srgbClr val="EDEDED"/>
+                    </a:solidFill>
+                  </a:tcPr>
+                </a:tc>
+                <a:tc>
+                  <a:txBody>
+                    <a:bodyPr/>
+                    <a:lstStyle/>
+                    <a:p>
+                      <a:pPr algn="ctr"/>
+                      <a:r>
+                        <a:rPr sz="1500" b="0" i="0" u="none">
+                          <a:solidFill>
+                            <a:srgbClr val="000000"/>
+                          </a:solidFill>
+                          <a:latin typeface="Times New Roman"/>
+                        </a:rPr>
+                        <a:t>1</a:t>
+                      </a:r>
+                    </a:p>
+                  </a:txBody>
+                  <a:tcPr anchor="ctr" marL="64008" marR="64008" marT="27432" marB="27432">
+                    <a:solidFill>
+                      <a:srgbClr val="EDEDED"/>
+                    </a:solidFill>
+                  </a:tcPr>
+                </a:tc>
+                <a:tc>
+                  <a:txBody>
+                    <a:bodyPr/>
+                    <a:lstStyle/>
+                    <a:p>
+                      <a:pPr algn="l"/>
+                      <a:r>
+                        <a:rPr sz="1500" b="0" i="0" u="none">
+                          <a:solidFill>
+                            <a:srgbClr val="000000"/>
+                          </a:solidFill>
+                          <a:latin typeface="Times New Roman"/>
+                        </a:rPr>
+                        <a:t>Reads the sensors and decides when to cut off</a:t>
+                      </a:r>
+                    </a:p>
+                  </a:txBody>
+                  <a:tcPr anchor="ctr" marL="64008" marR="64008" marT="27432" marB="27432">
+                    <a:solidFill>
+                      <a:srgbClr val="EDEDED"/>
+                    </a:solidFill>
+                  </a:tcPr>
+                </a:tc>
+              </a:tr>
+              <a:tr h="402336">
+                <a:tc>
+                  <a:txBody>
+                    <a:bodyPr/>
+                    <a:lstStyle/>
+                    <a:p>
+                      <a:pPr algn="l"/>
+                      <a:r>
+                        <a:rPr sz="1500" b="0" i="0" u="none">
+                          <a:solidFill>
+                            <a:srgbClr val="000000"/>
+                          </a:solidFill>
+                          <a:latin typeface="Times New Roman"/>
+                        </a:rPr>
+                        <a:t>NTC thermistors</a:t>
+                      </a:r>
+                    </a:p>
+                  </a:txBody>
+                  <a:tcPr anchor="ctr" marL="64008" marR="64008" marT="27432" marB="27432">
+                    <a:solidFill>
+                      <a:srgbClr val="FFFFFF"/>
+                    </a:solidFill>
+                  </a:tcPr>
+                </a:tc>
+                <a:tc>
+                  <a:txBody>
+                    <a:bodyPr/>
+                    <a:lstStyle/>
+                    <a:p>
+                      <a:pPr algn="ctr"/>
+                      <a:r>
+                        <a:rPr sz="1500" b="0" i="0" u="none">
+                          <a:solidFill>
+                            <a:srgbClr val="000000"/>
+                          </a:solidFill>
+                          <a:latin typeface="Times New Roman"/>
+                        </a:rPr>
+                        <a:t>4</a:t>
+                      </a:r>
+                    </a:p>
+                  </a:txBody>
+                  <a:tcPr anchor="ctr" marL="64008" marR="64008" marT="27432" marB="27432">
+                    <a:solidFill>
+                      <a:srgbClr val="FFFFFF"/>
+                    </a:solidFill>
+                  </a:tcPr>
+                </a:tc>
+                <a:tc>
+                  <a:txBody>
+                    <a:bodyPr/>
+                    <a:lstStyle/>
+                    <a:p>
+                      <a:pPr algn="l"/>
+                      <a:r>
+                        <a:rPr sz="1500" b="0" i="0" u="none">
+                          <a:solidFill>
+                            <a:srgbClr val="000000"/>
+                          </a:solidFill>
+                          <a:latin typeface="Times New Roman"/>
+                        </a:rPr>
+                        <a:t>Measure the temperature of each cell</a:t>
+                      </a:r>
+                    </a:p>
+                  </a:txBody>
+                  <a:tcPr anchor="ctr" marL="64008" marR="64008" marT="27432" marB="27432">
+                    <a:solidFill>
+                      <a:srgbClr val="FFFFFF"/>
+                    </a:solidFill>
+                  </a:tcPr>
+                </a:tc>
+              </a:tr>
+              <a:tr h="402336">
+                <a:tc>
+                  <a:txBody>
+                    <a:bodyPr/>
+                    <a:lstStyle/>
+                    <a:p>
+                      <a:pPr algn="l"/>
+                      <a:r>
+                        <a:rPr sz="1500" b="0" i="0" u="none">
+                          <a:solidFill>
+                            <a:srgbClr val="000000"/>
+                          </a:solidFill>
+                          <a:latin typeface="Times New Roman"/>
+                        </a:rPr>
+                        <a:t>Resistor dividers</a:t>
+                      </a:r>
+                    </a:p>
+                  </a:txBody>
+                  <a:tcPr anchor="ctr" marL="64008" marR="64008" marT="27432" marB="27432">
+                    <a:solidFill>
+                      <a:srgbClr val="EDEDED"/>
+                    </a:solidFill>
+                  </a:tcPr>
+                </a:tc>
+                <a:tc>
+                  <a:txBody>
+                    <a:bodyPr/>
+                    <a:lstStyle/>
+                    <a:p>
+                      <a:pPr algn="ctr"/>
+                      <a:r>
+                        <a:rPr sz="1500" b="0" i="0" u="none">
+                          <a:solidFill>
+                            <a:srgbClr val="000000"/>
+                          </a:solidFill>
+                          <a:latin typeface="Times New Roman"/>
+                        </a:rPr>
+                        <a:t>4</a:t>
+                      </a:r>
+                    </a:p>
+                  </a:txBody>
+                  <a:tcPr anchor="ctr" marL="64008" marR="64008" marT="27432" marB="27432">
+                    <a:solidFill>
+                      <a:srgbClr val="EDEDED"/>
+                    </a:solidFill>
+                  </a:tcPr>
+                </a:tc>
+                <a:tc>
+                  <a:txBody>
+                    <a:bodyPr/>
+                    <a:lstStyle/>
+                    <a:p>
+                      <a:pPr algn="l"/>
+                      <a:r>
+                        <a:rPr sz="1500" b="0" i="0" u="none">
+                          <a:solidFill>
+                            <a:srgbClr val="000000"/>
+                          </a:solidFill>
+                          <a:latin typeface="Times New Roman"/>
+                        </a:rPr>
+                        <a:t>Bring each cell voltage down to a level the ESP32 can read</a:t>
+                      </a:r>
+                    </a:p>
+                  </a:txBody>
+                  <a:tcPr anchor="ctr" marL="64008" marR="64008" marT="27432" marB="27432">
+                    <a:solidFill>
+                      <a:srgbClr val="EDEDED"/>
+                    </a:solidFill>
+                  </a:tcPr>
+                </a:tc>
+              </a:tr>
+              <a:tr h="402336">
+                <a:tc>
+                  <a:txBody>
+                    <a:bodyPr/>
+                    <a:lstStyle/>
+                    <a:p>
+                      <a:pPr algn="l"/>
+                      <a:r>
+                        <a:rPr sz="1500" b="0" i="0" u="none">
+                          <a:solidFill>
+                            <a:srgbClr val="000000"/>
+                          </a:solidFill>
+                          <a:latin typeface="Times New Roman"/>
+                        </a:rPr>
+                        <a:t>Current sensor with shunt</a:t>
+                      </a:r>
+                    </a:p>
+                  </a:txBody>
+                  <a:tcPr anchor="ctr" marL="64008" marR="64008" marT="27432" marB="27432">
+                    <a:solidFill>
+                      <a:srgbClr val="FFFFFF"/>
+                    </a:solidFill>
+                  </a:tcPr>
+                </a:tc>
+                <a:tc>
+                  <a:txBody>
+                    <a:bodyPr/>
+                    <a:lstStyle/>
+                    <a:p>
+                      <a:pPr algn="ctr"/>
+                      <a:r>
+                        <a:rPr sz="1500" b="0" i="0" u="none">
+                          <a:solidFill>
+                            <a:srgbClr val="000000"/>
+                          </a:solidFill>
+                          <a:latin typeface="Times New Roman"/>
+                        </a:rPr>
+                        <a:t>1</a:t>
+                      </a:r>
+                    </a:p>
+                  </a:txBody>
+                  <a:tcPr anchor="ctr" marL="64008" marR="64008" marT="27432" marB="27432">
+                    <a:solidFill>
+                      <a:srgbClr val="FFFFFF"/>
+                    </a:solidFill>
+                  </a:tcPr>
+                </a:tc>
+                <a:tc>
+                  <a:txBody>
+                    <a:bodyPr/>
+                    <a:lstStyle/>
+                    <a:p>
+                      <a:pPr algn="l"/>
+                      <a:r>
+                        <a:rPr sz="1500" b="0" i="0" u="none">
+                          <a:solidFill>
+                            <a:srgbClr val="000000"/>
+                          </a:solidFill>
+                          <a:latin typeface="Times New Roman"/>
+                        </a:rPr>
+                        <a:t>Measures the current going into and out of the pack</a:t>
+                      </a:r>
+                    </a:p>
+                  </a:txBody>
+                  <a:tcPr anchor="ctr" marL="64008" marR="64008" marT="27432" marB="27432">
+                    <a:solidFill>
+                      <a:srgbClr val="FFFFFF"/>
+                    </a:solidFill>
+                  </a:tcPr>
+                </a:tc>
+              </a:tr>
+              <a:tr h="402336">
+                <a:tc>
+                  <a:txBody>
+                    <a:bodyPr/>
+                    <a:lstStyle/>
+                    <a:p>
+                      <a:pPr algn="l"/>
+                      <a:r>
+                        <a:rPr sz="1500" b="0" i="0" u="none">
+                          <a:solidFill>
+                            <a:srgbClr val="000000"/>
+                          </a:solidFill>
+                          <a:latin typeface="Times New Roman"/>
+                        </a:rPr>
+                        <a:t>Analogue multiplexer</a:t>
+                      </a:r>
+                    </a:p>
+                  </a:txBody>
+                  <a:tcPr anchor="ctr" marL="64008" marR="64008" marT="27432" marB="27432">
+                    <a:solidFill>
+                      <a:srgbClr val="EDEDED"/>
+                    </a:solidFill>
+                  </a:tcPr>
+                </a:tc>
+                <a:tc>
+                  <a:txBody>
+                    <a:bodyPr/>
+                    <a:lstStyle/>
+                    <a:p>
+                      <a:pPr algn="ctr"/>
+                      <a:r>
+                        <a:rPr sz="1500" b="0" i="0" u="none">
+                          <a:solidFill>
+                            <a:srgbClr val="000000"/>
+                          </a:solidFill>
+                          <a:latin typeface="Times New Roman"/>
+                        </a:rPr>
+                        <a:t>1</a:t>
+                      </a:r>
+                    </a:p>
+                  </a:txBody>
+                  <a:tcPr anchor="ctr" marL="64008" marR="64008" marT="27432" marB="27432">
+                    <a:solidFill>
+                      <a:srgbClr val="EDEDED"/>
+                    </a:solidFill>
+                  </a:tcPr>
+                </a:tc>
+                <a:tc>
+                  <a:txBody>
+                    <a:bodyPr/>
+                    <a:lstStyle/>
+                    <a:p>
+                      <a:pPr algn="l"/>
+                      <a:r>
+                        <a:rPr sz="1500" b="0" i="0" u="none">
+                          <a:solidFill>
+                            <a:srgbClr val="000000"/>
+                          </a:solidFill>
+                          <a:latin typeface="Times New Roman"/>
+                        </a:rPr>
+                        <a:t>Lets one input pin read all four thermistors</a:t>
+                      </a:r>
+                    </a:p>
+                  </a:txBody>
+                  <a:tcPr anchor="ctr" marL="64008" marR="64008" marT="27432" marB="27432">
+                    <a:solidFill>
+                      <a:srgbClr val="EDEDED"/>
+                    </a:solidFill>
+                  </a:tcPr>
+                </a:tc>
+              </a:tr>
+              <a:tr h="402336">
+                <a:tc>
+                  <a:txBody>
+                    <a:bodyPr/>
+                    <a:lstStyle/>
+                    <a:p>
+                      <a:pPr algn="l"/>
+                      <a:r>
+                        <a:rPr sz="1500" b="0" i="0" u="none">
+                          <a:solidFill>
+                            <a:srgbClr val="000000"/>
+                          </a:solidFill>
+                          <a:latin typeface="Times New Roman"/>
+                        </a:rPr>
+                        <a:t>MOSFETs</a:t>
+                      </a:r>
+                    </a:p>
+                  </a:txBody>
+                  <a:tcPr anchor="ctr" marL="64008" marR="64008" marT="27432" marB="27432">
+                    <a:solidFill>
+                      <a:srgbClr val="FFFFFF"/>
+                    </a:solidFill>
+                  </a:tcPr>
+                </a:tc>
+                <a:tc>
+                  <a:txBody>
+                    <a:bodyPr/>
+                    <a:lstStyle/>
+                    <a:p>
+                      <a:pPr algn="ctr"/>
+                      <a:r>
+                        <a:rPr sz="1500" b="0" i="0" u="none">
+                          <a:solidFill>
+                            <a:srgbClr val="000000"/>
+                          </a:solidFill>
+                          <a:latin typeface="Times New Roman"/>
+                        </a:rPr>
+                        <a:t>2</a:t>
+                      </a:r>
+                    </a:p>
+                  </a:txBody>
+                  <a:tcPr anchor="ctr" marL="64008" marR="64008" marT="27432" marB="27432">
+                    <a:solidFill>
+                      <a:srgbClr val="FFFFFF"/>
+                    </a:solidFill>
+                  </a:tcPr>
+                </a:tc>
+                <a:tc>
+                  <a:txBody>
+                    <a:bodyPr/>
+                    <a:lstStyle/>
+                    <a:p>
+                      <a:pPr algn="l"/>
+                      <a:r>
+                        <a:rPr sz="1500" b="0" i="0" u="none">
+                          <a:solidFill>
+                            <a:srgbClr val="000000"/>
+                          </a:solidFill>
+                          <a:latin typeface="Times New Roman"/>
+                        </a:rPr>
+                        <a:t>The switches that stop charging and discharging</a:t>
+                      </a:r>
+                    </a:p>
+                  </a:txBody>
+                  <a:tcPr anchor="ctr" marL="64008" marR="64008" marT="27432" marB="27432">
+                    <a:solidFill>
+                      <a:srgbClr val="FFFFFF"/>
+                    </a:solidFill>
+                  </a:tcPr>
+                </a:tc>
+              </a:tr>
+              <a:tr h="402336">
+                <a:tc>
+                  <a:txBody>
+                    <a:bodyPr/>
+                    <a:lstStyle/>
+                    <a:p>
+                      <a:pPr algn="l"/>
+                      <a:r>
+                        <a:rPr sz="1500" b="0" i="0" u="none">
+                          <a:solidFill>
+                            <a:srgbClr val="000000"/>
+                          </a:solidFill>
+                          <a:latin typeface="Times New Roman"/>
+                        </a:rPr>
+                        <a:t>Bleed resistors</a:t>
+                      </a:r>
+                    </a:p>
+                  </a:txBody>
+                  <a:tcPr anchor="ctr" marL="64008" marR="64008" marT="27432" marB="27432">
+                    <a:solidFill>
+                      <a:srgbClr val="EDEDED"/>
+                    </a:solidFill>
+                  </a:tcPr>
+                </a:tc>
+                <a:tc>
+                  <a:txBody>
+                    <a:bodyPr/>
+                    <a:lstStyle/>
+                    <a:p>
+                      <a:pPr algn="ctr"/>
+                      <a:r>
+                        <a:rPr sz="1500" b="0" i="0" u="none">
+                          <a:solidFill>
+                            <a:srgbClr val="000000"/>
+                          </a:solidFill>
+                          <a:latin typeface="Times New Roman"/>
+                        </a:rPr>
+                        <a:t>4</a:t>
+                      </a:r>
+                    </a:p>
+                  </a:txBody>
+                  <a:tcPr anchor="ctr" marL="64008" marR="64008" marT="27432" marB="27432">
+                    <a:solidFill>
+                      <a:srgbClr val="EDEDED"/>
+                    </a:solidFill>
+                  </a:tcPr>
+                </a:tc>
+                <a:tc>
+                  <a:txBody>
+                    <a:bodyPr/>
+                    <a:lstStyle/>
+                    <a:p>
+                      <a:pPr algn="l"/>
+                      <a:r>
+                        <a:rPr sz="1500" b="0" i="0" u="none">
+                          <a:solidFill>
+                            <a:srgbClr val="000000"/>
+                          </a:solidFill>
+                          <a:latin typeface="Times New Roman"/>
+                        </a:rPr>
+                        <a:t>Drain a little charge from a cell that is fuller than the rest</a:t>
+                      </a:r>
+                    </a:p>
+                  </a:txBody>
+                  <a:tcPr anchor="ctr" marL="64008" marR="64008" marT="27432" marB="27432">
+                    <a:solidFill>
+                      <a:srgbClr val="EDEDED"/>
+                    </a:solidFill>
+                  </a:tcPr>
+                </a:tc>
+              </a:tr>
+              <a:tr h="402336">
+                <a:tc>
+                  <a:txBody>
+                    <a:bodyPr/>
+                    <a:lstStyle/>
+                    <a:p>
+                      <a:pPr algn="l"/>
+                      <a:r>
+                        <a:rPr sz="1500" b="0" i="0" u="none">
+                          <a:solidFill>
+                            <a:srgbClr val="000000"/>
+                          </a:solidFill>
+                          <a:latin typeface="Times New Roman"/>
+                        </a:rPr>
+                        <a:t>Buck converter</a:t>
+                      </a:r>
+                    </a:p>
+                  </a:txBody>
+                  <a:tcPr anchor="ctr" marL="64008" marR="64008" marT="27432" marB="27432">
+                    <a:solidFill>
+                      <a:srgbClr val="FFFFFF"/>
+                    </a:solidFill>
+                  </a:tcPr>
+                </a:tc>
+                <a:tc>
+                  <a:txBody>
+                    <a:bodyPr/>
+                    <a:lstStyle/>
+                    <a:p>
+                      <a:pPr algn="ctr"/>
+                      <a:r>
+                        <a:rPr sz="1500" b="0" i="0" u="none">
+                          <a:solidFill>
+                            <a:srgbClr val="000000"/>
+                          </a:solidFill>
+                          <a:latin typeface="Times New Roman"/>
+                        </a:rPr>
+                        <a:t>1</a:t>
+                      </a:r>
+                    </a:p>
+                  </a:txBody>
+                  <a:tcPr anchor="ctr" marL="64008" marR="64008" marT="27432" marB="27432">
+                    <a:solidFill>
+                      <a:srgbClr val="FFFFFF"/>
+                    </a:solidFill>
+                  </a:tcPr>
+                </a:tc>
+                <a:tc>
+                  <a:txBody>
+                    <a:bodyPr/>
+                    <a:lstStyle/>
+                    <a:p>
+                      <a:pPr algn="l"/>
+                      <a:r>
+                        <a:rPr sz="1500" b="0" i="0" u="none">
+                          <a:solidFill>
+                            <a:srgbClr val="000000"/>
+                          </a:solidFill>
+                          <a:latin typeface="Times New Roman"/>
+                        </a:rPr>
+                        <a:t>Makes the 3.3 V supply for the ESP32 from the pack</a:t>
+                      </a:r>
+                    </a:p>
+                  </a:txBody>
+                  <a:tcPr anchor="ctr" marL="64008" marR="64008" marT="27432" marB="27432">
+                    <a:solidFill>
+                      <a:srgbClr val="FFFFFF"/>
+                    </a:solidFill>
+                  </a:tcPr>
+                </a:tc>
+              </a:tr>
+              <a:tr h="402336">
+                <a:tc>
+                  <a:txBody>
+                    <a:bodyPr/>
+                    <a:lstStyle/>
+                    <a:p>
+                      <a:pPr algn="l"/>
+                      <a:r>
+                        <a:rPr sz="1500" b="0" i="0" u="none">
+                          <a:solidFill>
+                            <a:srgbClr val="000000"/>
+                          </a:solidFill>
+                          <a:latin typeface="Times New Roman"/>
+                        </a:rPr>
+                        <a:t>Fuse</a:t>
+                      </a:r>
+                    </a:p>
+                  </a:txBody>
+                  <a:tcPr anchor="ctr" marL="64008" marR="64008" marT="27432" marB="27432">
+                    <a:solidFill>
+                      <a:srgbClr val="EDEDED"/>
+                    </a:solidFill>
+                  </a:tcPr>
+                </a:tc>
+                <a:tc>
+                  <a:txBody>
+                    <a:bodyPr/>
+                    <a:lstStyle/>
+                    <a:p>
+                      <a:pPr algn="ctr"/>
+                      <a:r>
+                        <a:rPr sz="1500" b="0" i="0" u="none">
+                          <a:solidFill>
+                            <a:srgbClr val="000000"/>
+                          </a:solidFill>
+                          <a:latin typeface="Times New Roman"/>
+                        </a:rPr>
+                        <a:t>1</a:t>
+                      </a:r>
+                    </a:p>
+                  </a:txBody>
+                  <a:tcPr anchor="ctr" marL="64008" marR="64008" marT="27432" marB="27432">
+                    <a:solidFill>
+                      <a:srgbClr val="EDEDED"/>
+                    </a:solidFill>
+                  </a:tcPr>
+                </a:tc>
+                <a:tc>
+                  <a:txBody>
+                    <a:bodyPr/>
+                    <a:lstStyle/>
+                    <a:p>
+                      <a:pPr algn="l"/>
+                      <a:r>
+                        <a:rPr sz="1500" b="0" i="0" u="none">
+                          <a:solidFill>
+                            <a:srgbClr val="000000"/>
+                          </a:solidFill>
+                          <a:latin typeface="Times New Roman"/>
+                        </a:rPr>
+                        <a:t>The last protection if the electronics fail</a:t>
+                      </a:r>
+                    </a:p>
+                  </a:txBody>
+                  <a:tcPr anchor="ctr" marL="64008" marR="64008" marT="27432" marB="27432">
+                    <a:solidFill>
+                      <a:srgbClr val="EDEDED"/>
+                    </a:solidFill>
+                  </a:tcPr>
+                </a:tc>
+              </a:tr>
+            </a:tbl>
+          </a:graphicData>
+        </a:graphic>
+      </p:graphicFrame>
+    </p:spTree>
+  </p:cSld>
+  <p:clrMapOvr>
+    <a:masterClrMapping/>
+  </p:clrMapOvr>
+</p:sld>
+</file>
+
+<file path=ppt/slides/slide7.xml><?xml version="1.0" encoding="utf-8"?>
+<p:sld xmlns:a="http://schemas.openxmlformats.org/drawingml/2006/main" xmlns:p="http://schemas.openxmlformats.org/presentationml/2006/main" xmlns:r="http://schemas.openxmlformats.org/officeDocument/2006/relationships">
+  <p:cSld>
+    <p:spTree>
+      <p:nvGrpSpPr>
+        <p:cNvPr id="1" name=""/>
+        <p:cNvGrpSpPr/>
+        <p:nvPr/>
+      </p:nvGrpSpPr>
+      <p:grpSpPr/>
+      <p:pic>
+        <p:nvPicPr>
+          <p:cNvPr id="2" name="Picture 1" descr="logo.png"/>
+          <p:cNvPicPr>
+            <a:picLocks noChangeAspect="1"/>
+          </p:cNvPicPr>
+          <p:nvPr/>
+        </p:nvPicPr>
+        <p:blipFill>
+          <a:blip r:embed="rId2"/>
+          <a:stretch>
+            <a:fillRect/>
+          </a:stretch>
+        </p:blipFill>
+        <p:spPr>
+          <a:xfrm>
+            <a:off x="286207" y="109728"/>
+            <a:ext cx="646480" cy="950976"/>
+          </a:xfrm>
+          <a:prstGeom prst="rect">
+            <a:avLst/>
+          </a:prstGeom>
+        </p:spPr>
+      </p:pic>
+      <p:sp>
+        <p:nvSpPr>
+          <p:cNvPr id="3" name="TextBox 2"/>
+          <p:cNvSpPr txBox="1"/>
+          <p:nvPr/>
+        </p:nvSpPr>
+        <p:spPr>
+          <a:xfrm>
+            <a:off x="1188720" y="384048"/>
+            <a:ext cx="9814255" cy="548640"/>
+          </a:xfrm>
+          <a:prstGeom prst="rect">
+            <a:avLst/>
+          </a:prstGeom>
+          <a:noFill/>
+        </p:spPr>
+        <p:txBody>
+          <a:bodyPr wrap="square" lIns="0" rIns="0" tIns="0" bIns="0">
+            <a:noAutofit/>
+          </a:bodyPr>
+          <a:lstStyle/>
+          <a:p>
+            <a:pPr algn="ctr"/>
+            <a:r>
+              <a:rPr sz="2400" b="1" i="0" u="sng">
+                <a:solidFill>
+                  <a:srgbClr val="000000"/>
+                </a:solidFill>
+                <a:latin typeface="Times New Roman"/>
+              </a:rPr>
+              <a:t>Implementation and Tools</a:t>
+            </a:r>
+          </a:p>
+        </p:txBody>
+      </p:sp>
+      <p:sp>
+        <p:nvSpPr>
+          <p:cNvPr id="4" name="TextBox 3"/>
+          <p:cNvSpPr txBox="1"/>
+          <p:nvPr/>
+        </p:nvSpPr>
+        <p:spPr>
+          <a:xfrm>
+            <a:off x="929944" y="6355080"/>
+            <a:ext cx="2286000" cy="292608"/>
+          </a:xfrm>
+          <a:prstGeom prst="rect">
+            <a:avLst/>
+          </a:prstGeom>
+          <a:noFill/>
+        </p:spPr>
+        <p:txBody>
+          <a:bodyPr wrap="square" lIns="0" rIns="0" tIns="0" bIns="0">
+            <a:noAutofit/>
+          </a:bodyPr>
+          <a:lstStyle/>
+          <a:p>
+            <a:r>
+              <a:rPr sz="1200" b="0" i="0" u="none">
+                <a:solidFill>
+                  <a:srgbClr val="898989"/>
+                </a:solidFill>
+                <a:latin typeface="Calibri"/>
+              </a:rPr>
+              <a:t>22-07-2026</a:t>
+            </a:r>
+          </a:p>
+        </p:txBody>
+      </p:sp>
+      <p:sp>
+        <p:nvSpPr>
+          <p:cNvPr id="5" name="TextBox 4"/>
+          <p:cNvSpPr txBox="1"/>
+          <p:nvPr/>
+        </p:nvSpPr>
+        <p:spPr>
+          <a:xfrm>
+            <a:off x="3931920" y="6355080"/>
+            <a:ext cx="4297680" cy="292608"/>
+          </a:xfrm>
+          <a:prstGeom prst="rect">
+            <a:avLst/>
+          </a:prstGeom>
+          <a:noFill/>
+        </p:spPr>
+        <p:txBody>
+          <a:bodyPr wrap="square" lIns="0" rIns="0" tIns="0" bIns="0">
+            <a:noAutofit/>
+          </a:bodyPr>
+          <a:lstStyle/>
+          <a:p>
+            <a:pPr algn="ctr"/>
+            <a:r>
+              <a:rPr sz="1200" b="0" i="0" u="none">
+                <a:solidFill>
+                  <a:srgbClr val="898989"/>
+                </a:solidFill>
+                <a:latin typeface="Calibri"/>
+              </a:rPr>
+              <a:t>Zeroth Review-2026-27</a:t>
+            </a:r>
+          </a:p>
+        </p:txBody>
+      </p:sp>
+      <p:sp>
+        <p:nvSpPr>
+          <p:cNvPr id="6" name="TextBox 5"/>
+          <p:cNvSpPr txBox="1"/>
+          <p:nvPr/>
+        </p:nvSpPr>
+        <p:spPr>
+          <a:xfrm>
+            <a:off x="10058400" y="6355080"/>
+            <a:ext cx="1204264" cy="292608"/>
+          </a:xfrm>
+          <a:prstGeom prst="rect">
+            <a:avLst/>
+          </a:prstGeom>
+          <a:noFill/>
+        </p:spPr>
+        <p:txBody>
+          <a:bodyPr wrap="square" lIns="0" rIns="0" tIns="0" bIns="0">
+            <a:noAutofit/>
+          </a:bodyPr>
+          <a:lstStyle/>
+          <a:p>
+            <a:pPr algn="r"/>
+            <a:r>
+              <a:rPr sz="1200" b="0" i="0" u="none">
+                <a:solidFill>
+                  <a:srgbClr val="898989"/>
+                </a:solidFill>
+                <a:latin typeface="Calibri"/>
+              </a:rPr>
+              <a:t>7</a:t>
             </a:r>
           </a:p>
         </p:txBody>
@@ -6956,7 +8285,7 @@
 </p:sld>
 </file>
 
-<file path=ppt/slides/slide7.xml><?xml version="1.0" encoding="utf-8"?>
+<file path=ppt/slides/slide8.xml><?xml version="1.0" encoding="utf-8"?>
 <p:sld xmlns:a="http://schemas.openxmlformats.org/drawingml/2006/main" xmlns:p="http://schemas.openxmlformats.org/presentationml/2006/main" xmlns:r="http://schemas.openxmlformats.org/officeDocument/2006/relationships">
   <p:cSld>
     <p:spTree>
@@ -7124,7 +8453,7 @@
                 </a:solidFill>
                 <a:latin typeface="Calibri"/>
               </a:rPr>
-              <a:t>7</a:t>
+              <a:t>8</a:t>
             </a:r>
           </a:p>
         </p:txBody>
@@ -7451,355 +8780,6 @@
 </p:sld>
 </file>
 
-<file path=ppt/slides/slide8.xml><?xml version="1.0" encoding="utf-8"?>
-<p:sld xmlns:a="http://schemas.openxmlformats.org/drawingml/2006/main" xmlns:p="http://schemas.openxmlformats.org/presentationml/2006/main" xmlns:r="http://schemas.openxmlformats.org/officeDocument/2006/relationships">
-  <p:cSld>
-    <p:spTree>
-      <p:nvGrpSpPr>
-        <p:cNvPr id="1" name=""/>
-        <p:cNvGrpSpPr/>
-        <p:nvPr/>
-      </p:nvGrpSpPr>
-      <p:grpSpPr/>
-      <p:pic>
-        <p:nvPicPr>
-          <p:cNvPr id="2" name="Picture 1" descr="logo.png"/>
-          <p:cNvPicPr>
-            <a:picLocks noChangeAspect="1"/>
-          </p:cNvPicPr>
-          <p:nvPr/>
-        </p:nvPicPr>
-        <p:blipFill>
-          <a:blip r:embed="rId2"/>
-          <a:stretch>
-            <a:fillRect/>
-          </a:stretch>
-        </p:blipFill>
-        <p:spPr>
-          <a:xfrm>
-            <a:off x="286207" y="109728"/>
-            <a:ext cx="646480" cy="950976"/>
-          </a:xfrm>
-          <a:prstGeom prst="rect">
-            <a:avLst/>
-          </a:prstGeom>
-        </p:spPr>
-      </p:pic>
-      <p:sp>
-        <p:nvSpPr>
-          <p:cNvPr id="3" name="TextBox 2"/>
-          <p:cNvSpPr txBox="1"/>
-          <p:nvPr/>
-        </p:nvSpPr>
-        <p:spPr>
-          <a:xfrm>
-            <a:off x="1188720" y="384048"/>
-            <a:ext cx="9814255" cy="548640"/>
-          </a:xfrm>
-          <a:prstGeom prst="rect">
-            <a:avLst/>
-          </a:prstGeom>
-          <a:noFill/>
-        </p:spPr>
-        <p:txBody>
-          <a:bodyPr wrap="square" lIns="0" rIns="0" tIns="0" bIns="0">
-            <a:noAutofit/>
-          </a:bodyPr>
-          <a:lstStyle/>
-          <a:p>
-            <a:pPr algn="ctr"/>
-            <a:r>
-              <a:rPr sz="2400" b="1" i="0" u="sng">
-                <a:solidFill>
-                  <a:srgbClr val="000000"/>
-                </a:solidFill>
-                <a:latin typeface="Times New Roman"/>
-              </a:rPr>
-              <a:t>References</a:t>
-            </a:r>
-          </a:p>
-        </p:txBody>
-      </p:sp>
-      <p:sp>
-        <p:nvSpPr>
-          <p:cNvPr id="4" name="TextBox 3"/>
-          <p:cNvSpPr txBox="1"/>
-          <p:nvPr/>
-        </p:nvSpPr>
-        <p:spPr>
-          <a:xfrm>
-            <a:off x="929944" y="6355080"/>
-            <a:ext cx="2286000" cy="292608"/>
-          </a:xfrm>
-          <a:prstGeom prst="rect">
-            <a:avLst/>
-          </a:prstGeom>
-          <a:noFill/>
-        </p:spPr>
-        <p:txBody>
-          <a:bodyPr wrap="square" lIns="0" rIns="0" tIns="0" bIns="0">
-            <a:noAutofit/>
-          </a:bodyPr>
-          <a:lstStyle/>
-          <a:p>
-            <a:r>
-              <a:rPr sz="1200" b="0" i="0" u="none">
-                <a:solidFill>
-                  <a:srgbClr val="898989"/>
-                </a:solidFill>
-                <a:latin typeface="Calibri"/>
-              </a:rPr>
-              <a:t>22-07-2026</a:t>
-            </a:r>
-          </a:p>
-        </p:txBody>
-      </p:sp>
-      <p:sp>
-        <p:nvSpPr>
-          <p:cNvPr id="5" name="TextBox 4"/>
-          <p:cNvSpPr txBox="1"/>
-          <p:nvPr/>
-        </p:nvSpPr>
-        <p:spPr>
-          <a:xfrm>
-            <a:off x="3931920" y="6355080"/>
-            <a:ext cx="4297680" cy="292608"/>
-          </a:xfrm>
-          <a:prstGeom prst="rect">
-            <a:avLst/>
-          </a:prstGeom>
-          <a:noFill/>
-        </p:spPr>
-        <p:txBody>
-          <a:bodyPr wrap="square" lIns="0" rIns="0" tIns="0" bIns="0">
-            <a:noAutofit/>
-          </a:bodyPr>
-          <a:lstStyle/>
-          <a:p>
-            <a:pPr algn="ctr"/>
-            <a:r>
-              <a:rPr sz="1200" b="0" i="0" u="none">
-                <a:solidFill>
-                  <a:srgbClr val="898989"/>
-                </a:solidFill>
-                <a:latin typeface="Calibri"/>
-              </a:rPr>
-              <a:t>Zeroth Review-2026-27</a:t>
-            </a:r>
-          </a:p>
-        </p:txBody>
-      </p:sp>
-      <p:sp>
-        <p:nvSpPr>
-          <p:cNvPr id="6" name="TextBox 5"/>
-          <p:cNvSpPr txBox="1"/>
-          <p:nvPr/>
-        </p:nvSpPr>
-        <p:spPr>
-          <a:xfrm>
-            <a:off x="10058400" y="6355080"/>
-            <a:ext cx="1204264" cy="292608"/>
-          </a:xfrm>
-          <a:prstGeom prst="rect">
-            <a:avLst/>
-          </a:prstGeom>
-          <a:noFill/>
-        </p:spPr>
-        <p:txBody>
-          <a:bodyPr wrap="square" lIns="0" rIns="0" tIns="0" bIns="0">
-            <a:noAutofit/>
-          </a:bodyPr>
-          <a:lstStyle/>
-          <a:p>
-            <a:pPr algn="r"/>
-            <a:r>
-              <a:rPr sz="1200" b="0" i="0" u="none">
-                <a:solidFill>
-                  <a:srgbClr val="898989"/>
-                </a:solidFill>
-                <a:latin typeface="Calibri"/>
-              </a:rPr>
-              <a:t>8</a:t>
-            </a:r>
-          </a:p>
-        </p:txBody>
-      </p:sp>
-      <p:sp>
-        <p:nvSpPr>
-          <p:cNvPr id="7" name="TextBox 6"/>
-          <p:cNvSpPr txBox="1"/>
-          <p:nvPr/>
-        </p:nvSpPr>
-        <p:spPr>
-          <a:xfrm>
-            <a:off x="1168603" y="1389888"/>
-            <a:ext cx="10195560" cy="4754879"/>
-          </a:xfrm>
-          <a:prstGeom prst="rect">
-            <a:avLst/>
-          </a:prstGeom>
-          <a:noFill/>
-        </p:spPr>
-        <p:txBody>
-          <a:bodyPr wrap="square" lIns="0" rIns="0" tIns="0" bIns="0">
-            <a:noAutofit/>
-          </a:bodyPr>
-          <a:lstStyle/>
-          <a:p>
-            <a:pPr marL="384048" indent="-384048">
-              <a:lnSpc>
-                <a:spcPct val="110000"/>
-              </a:lnSpc>
-              <a:spcAft>
-                <a:spcPts val="2000"/>
-              </a:spcAft>
-              <a:buNone/>
-            </a:pPr>
-            <a:r>
-              <a:rPr sz="1400" b="0" i="0" u="none">
-                <a:solidFill>
-                  <a:srgbClr val="000000"/>
-                </a:solidFill>
-                <a:latin typeface="Times New Roman"/>
-              </a:rPr>
-              <a:t>[1]  </a:t>
-            </a:r>
-            <a:r>
-              <a:rPr sz="1400" b="0" i="0" u="none">
-                <a:solidFill>
-                  <a:srgbClr val="000000"/>
-                </a:solidFill>
-                <a:latin typeface="Times New Roman"/>
-              </a:rPr>
-              <a:t>X. Feng, M. Ouyang, X. Liu, L. Lu, Y. Xia and X. He, “Thermal runaway mechanism of lithium ion battery for electric vehicles: A review,” Energy Storage Materials, vol. 10, pp. 246–267, 2018.</a:t>
-            </a:r>
-          </a:p>
-          <a:p>
-            <a:pPr marL="384048" indent="-384048">
-              <a:lnSpc>
-                <a:spcPct val="110000"/>
-              </a:lnSpc>
-              <a:spcAft>
-                <a:spcPts val="2000"/>
-              </a:spcAft>
-              <a:buNone/>
-            </a:pPr>
-            <a:r>
-              <a:rPr sz="1400" b="0" i="0" u="none">
-                <a:solidFill>
-                  <a:srgbClr val="000000"/>
-                </a:solidFill>
-                <a:latin typeface="Times New Roman"/>
-              </a:rPr>
-              <a:t>[2]  </a:t>
-            </a:r>
-            <a:r>
-              <a:rPr sz="1400" b="0" i="0" u="none">
-                <a:solidFill>
-                  <a:srgbClr val="000000"/>
-                </a:solidFill>
-                <a:latin typeface="Times New Roman"/>
-              </a:rPr>
-              <a:t>X. Zhang, S. Chen, J. Zhu et al., “A critical review of thermal runaway prediction and early-warning methods for lithium-ion batteries,” Energy Material Advances, vol. 4, art. 0008, 2023.</a:t>
-            </a:r>
-          </a:p>
-          <a:p>
-            <a:pPr marL="384048" indent="-384048">
-              <a:lnSpc>
-                <a:spcPct val="110000"/>
-              </a:lnSpc>
-              <a:spcAft>
-                <a:spcPts val="2000"/>
-              </a:spcAft>
-              <a:buNone/>
-            </a:pPr>
-            <a:r>
-              <a:rPr sz="1400" b="0" i="0" u="none">
-                <a:solidFill>
-                  <a:srgbClr val="000000"/>
-                </a:solidFill>
-                <a:latin typeface="Times New Roman"/>
-              </a:rPr>
-              <a:t>[3]  </a:t>
-            </a:r>
-            <a:r>
-              <a:rPr sz="1400" b="0" i="0" u="none">
-                <a:solidFill>
-                  <a:srgbClr val="000000"/>
-                </a:solidFill>
-                <a:latin typeface="Times New Roman"/>
-              </a:rPr>
-              <a:t>Q. Chen, Y. He, N. Fang and G. Yu, “A combined data-driven and model-based algorithm for accurate battery thermal runaway warning,” Sensors, vol. 24, no. 15, art. 4964, 2024.</a:t>
-            </a:r>
-          </a:p>
-          <a:p>
-            <a:pPr marL="384048" indent="-384048">
-              <a:lnSpc>
-                <a:spcPct val="110000"/>
-              </a:lnSpc>
-              <a:spcAft>
-                <a:spcPts val="2000"/>
-              </a:spcAft>
-              <a:buNone/>
-            </a:pPr>
-            <a:r>
-              <a:rPr sz="1400" b="0" i="0" u="none">
-                <a:solidFill>
-                  <a:srgbClr val="000000"/>
-                </a:solidFill>
-                <a:latin typeface="Times New Roman"/>
-              </a:rPr>
-              <a:t>[4]  </a:t>
-            </a:r>
-            <a:r>
-              <a:rPr sz="1400" b="0" i="0" u="none">
-                <a:solidFill>
-                  <a:srgbClr val="000000"/>
-                </a:solidFill>
-                <a:latin typeface="Times New Roman"/>
-              </a:rPr>
-              <a:t>A. K. M. A. Habib, M. K. Hasan, G. F. Issa, D. Singh, S. Islam and T. M. Ghazal, “Lithium-ion battery management system for electric vehicles: Constraints, challenges and recommendations,” Batteries, vol. 9, no. 3, art. 152, 2023.</a:t>
-            </a:r>
-          </a:p>
-          <a:p>
-            <a:pPr marL="384048" indent="-384048">
-              <a:lnSpc>
-                <a:spcPct val="110000"/>
-              </a:lnSpc>
-              <a:spcAft>
-                <a:spcPts val="2000"/>
-              </a:spcAft>
-              <a:buNone/>
-            </a:pPr>
-            <a:r>
-              <a:rPr sz="1400" b="0" i="0" u="none">
-                <a:solidFill>
-                  <a:srgbClr val="000000"/>
-                </a:solidFill>
-                <a:latin typeface="Times New Roman"/>
-              </a:rPr>
-              <a:t>[5]  </a:t>
-            </a:r>
-            <a:r>
-              <a:rPr sz="1400" b="0" i="0" u="none">
-                <a:solidFill>
-                  <a:srgbClr val="000000"/>
-                </a:solidFill>
-                <a:latin typeface="Times New Roman"/>
-              </a:rPr>
-              <a:t>IS 16046 (Part 2) : 2018 / IEC 62133-2 : 2017, Secondary cells and batteries containing alkaline or other non-acid electrolytes — Part 2: Lithium systems.</a:t>
-            </a:r>
-          </a:p>
-        </p:txBody>
-      </p:sp>
-    </p:spTree>
-  </p:cSld>
-  <p:clrMapOvr>
-    <a:masterClrMapping/>
-  </p:clrMapOvr>
-</p:sld>
-</file>
-
 <file path=ppt/slides/slide9.xml><?xml version="1.0" encoding="utf-8"?>
 <p:sld xmlns:a="http://schemas.openxmlformats.org/drawingml/2006/main" xmlns:p="http://schemas.openxmlformats.org/presentationml/2006/main" xmlns:r="http://schemas.openxmlformats.org/officeDocument/2006/relationships">
   <p:cSld>
@@ -7842,6 +8822,41 @@
         </p:nvSpPr>
         <p:spPr>
           <a:xfrm>
+            <a:off x="1188720" y="384048"/>
+            <a:ext cx="9814255" cy="548640"/>
+          </a:xfrm>
+          <a:prstGeom prst="rect">
+            <a:avLst/>
+          </a:prstGeom>
+          <a:noFill/>
+        </p:spPr>
+        <p:txBody>
+          <a:bodyPr wrap="square" lIns="0" rIns="0" tIns="0" bIns="0">
+            <a:noAutofit/>
+          </a:bodyPr>
+          <a:lstStyle/>
+          <a:p>
+            <a:pPr algn="ctr"/>
+            <a:r>
+              <a:rPr sz="2400" b="1" i="0" u="sng">
+                <a:solidFill>
+                  <a:srgbClr val="000000"/>
+                </a:solidFill>
+                <a:latin typeface="Times New Roman"/>
+              </a:rPr>
+              <a:t>References</a:t>
+            </a:r>
+          </a:p>
+        </p:txBody>
+      </p:sp>
+      <p:sp>
+        <p:nvSpPr>
+          <p:cNvPr id="4" name="TextBox 3"/>
+          <p:cNvSpPr txBox="1"/>
+          <p:nvPr/>
+        </p:nvSpPr>
+        <p:spPr>
+          <a:xfrm>
             <a:off x="929944" y="6355080"/>
             <a:ext cx="2286000" cy="292608"/>
           </a:xfrm>
@@ -7870,7 +8885,7 @@
       </p:sp>
       <p:sp>
         <p:nvSpPr>
-          <p:cNvPr id="4" name="TextBox 3"/>
+          <p:cNvPr id="5" name="TextBox 4"/>
           <p:cNvSpPr txBox="1"/>
           <p:nvPr/>
         </p:nvSpPr>
@@ -7905,7 +8920,7 @@
       </p:sp>
       <p:sp>
         <p:nvSpPr>
-          <p:cNvPr id="5" name="TextBox 4"/>
+          <p:cNvPr id="6" name="TextBox 5"/>
           <p:cNvSpPr txBox="1"/>
           <p:nvPr/>
         </p:nvSpPr>
@@ -7940,14 +8955,14 @@
       </p:sp>
       <p:sp>
         <p:nvSpPr>
-          <p:cNvPr id="6" name="TextBox 5"/>
+          <p:cNvPr id="7" name="TextBox 6"/>
           <p:cNvSpPr txBox="1"/>
           <p:nvPr/>
         </p:nvSpPr>
         <p:spPr>
           <a:xfrm>
-            <a:off x="1188720" y="2606040"/>
-            <a:ext cx="9814255" cy="1463040"/>
+            <a:off x="1168603" y="1389888"/>
+            <a:ext cx="10195560" cy="4754879"/>
           </a:xfrm>
           <a:prstGeom prst="rect">
             <a:avLst/>
@@ -7960,39 +8975,148 @@
           </a:bodyPr>
           <a:lstStyle/>
           <a:p>
-            <a:pPr algn="ctr"/>
-            <a:r>
-              <a:rPr sz="4000" b="1" i="0" u="none">
+            <a:pPr marL="384048" indent="-384048">
+              <a:lnSpc>
+                <a:spcPct val="110000"/>
+              </a:lnSpc>
+              <a:spcAft>
+                <a:spcPts val="2000"/>
+              </a:spcAft>
+              <a:buNone/>
+            </a:pPr>
+            <a:r>
+              <a:rPr sz="1400" b="0" i="0" u="none">
                 <a:solidFill>
                   <a:srgbClr val="000000"/>
                 </a:solidFill>
                 <a:latin typeface="Times New Roman"/>
               </a:rPr>
-              <a:t>Thank You</a:t>
-            </a:r>
-          </a:p>
-          <a:p>
-            <a:pPr algn="ctr"/>
-            <a:r>
-              <a:rPr sz="1800" b="0" i="0" u="none">
+              <a:t>[1]  </a:t>
+            </a:r>
+            <a:r>
+              <a:rPr sz="1400" b="0" i="0" u="none">
                 <a:solidFill>
                   <a:srgbClr val="000000"/>
                 </a:solidFill>
                 <a:latin typeface="Times New Roman"/>
               </a:rPr>
-              <a:t/>
-            </a:r>
-          </a:p>
-          <a:p>
-            <a:pPr algn="ctr"/>
-            <a:r>
-              <a:rPr sz="2000" b="0" i="0" u="none">
-                <a:solidFill>
-                  <a:srgbClr val="002060"/>
+              <a:t>X. Feng, M. Ouyang, X. Liu, L. Lu, Y. Xia and X. He, “Thermal runaway mechanism of lithium ion battery for electric vehicles: A review,” Energy Storage Materials, vol. 10, pp. 246–267, 2018.</a:t>
+            </a:r>
+          </a:p>
+          <a:p>
+            <a:pPr marL="384048" indent="-384048">
+              <a:lnSpc>
+                <a:spcPct val="110000"/>
+              </a:lnSpc>
+              <a:spcAft>
+                <a:spcPts val="2000"/>
+              </a:spcAft>
+              <a:buNone/>
+            </a:pPr>
+            <a:r>
+              <a:rPr sz="1400" b="0" i="0" u="none">
+                <a:solidFill>
+                  <a:srgbClr val="000000"/>
                 </a:solidFill>
                 <a:latin typeface="Times New Roman"/>
               </a:rPr>
-              <a:t>Questions are welcome</a:t>
+              <a:t>[2]  </a:t>
+            </a:r>
+            <a:r>
+              <a:rPr sz="1400" b="0" i="0" u="none">
+                <a:solidFill>
+                  <a:srgbClr val="000000"/>
+                </a:solidFill>
+                <a:latin typeface="Times New Roman"/>
+              </a:rPr>
+              <a:t>X. Zhang, S. Chen, J. Zhu et al., “A critical review of thermal runaway prediction and early-warning methods for lithium-ion batteries,” Energy Material Advances, vol. 4, art. 0008, 2023.</a:t>
+            </a:r>
+          </a:p>
+          <a:p>
+            <a:pPr marL="384048" indent="-384048">
+              <a:lnSpc>
+                <a:spcPct val="110000"/>
+              </a:lnSpc>
+              <a:spcAft>
+                <a:spcPts val="2000"/>
+              </a:spcAft>
+              <a:buNone/>
+            </a:pPr>
+            <a:r>
+              <a:rPr sz="1400" b="0" i="0" u="none">
+                <a:solidFill>
+                  <a:srgbClr val="000000"/>
+                </a:solidFill>
+                <a:latin typeface="Times New Roman"/>
+              </a:rPr>
+              <a:t>[3]  </a:t>
+            </a:r>
+            <a:r>
+              <a:rPr sz="1400" b="0" i="0" u="none">
+                <a:solidFill>
+                  <a:srgbClr val="000000"/>
+                </a:solidFill>
+                <a:latin typeface="Times New Roman"/>
+              </a:rPr>
+              <a:t>Q. Chen, Y. He, N. Fang and G. Yu, “A combined data-driven and model-based algorithm for accurate battery thermal runaway warning,” Sensors, vol. 24, no. 15, art. 4964, 2024.</a:t>
+            </a:r>
+          </a:p>
+          <a:p>
+            <a:pPr marL="384048" indent="-384048">
+              <a:lnSpc>
+                <a:spcPct val="110000"/>
+              </a:lnSpc>
+              <a:spcAft>
+                <a:spcPts val="2000"/>
+              </a:spcAft>
+              <a:buNone/>
+            </a:pPr>
+            <a:r>
+              <a:rPr sz="1400" b="0" i="0" u="none">
+                <a:solidFill>
+                  <a:srgbClr val="000000"/>
+                </a:solidFill>
+                <a:latin typeface="Times New Roman"/>
+              </a:rPr>
+              <a:t>[4]  </a:t>
+            </a:r>
+            <a:r>
+              <a:rPr sz="1400" b="0" i="0" u="none">
+                <a:solidFill>
+                  <a:srgbClr val="000000"/>
+                </a:solidFill>
+                <a:latin typeface="Times New Roman"/>
+              </a:rPr>
+              <a:t>A. K. M. A. Habib, M. K. Hasan, G. F. Issa, D. Singh, S. Islam and T. M. Ghazal, “Lithium-ion battery management system for electric vehicles: Constraints, challenges and recommendations,” Batteries, vol. 9, no. 3, art. 152, 2023.</a:t>
+            </a:r>
+          </a:p>
+          <a:p>
+            <a:pPr marL="384048" indent="-384048">
+              <a:lnSpc>
+                <a:spcPct val="110000"/>
+              </a:lnSpc>
+              <a:spcAft>
+                <a:spcPts val="2000"/>
+              </a:spcAft>
+              <a:buNone/>
+            </a:pPr>
+            <a:r>
+              <a:rPr sz="1400" b="0" i="0" u="none">
+                <a:solidFill>
+                  <a:srgbClr val="000000"/>
+                </a:solidFill>
+                <a:latin typeface="Times New Roman"/>
+              </a:rPr>
+              <a:t>[5]  </a:t>
+            </a:r>
+            <a:r>
+              <a:rPr sz="1400" b="0" i="0" u="none">
+                <a:solidFill>
+                  <a:srgbClr val="000000"/>
+                </a:solidFill>
+                <a:latin typeface="Times New Roman"/>
+              </a:rPr>
+              <a:t>IS 16046 (Part 2) : 2018 / IEC 62133-2 : 2017, Secondary cells and batteries containing alkaline or other non-acid electrolytes — Part 2: Lithium systems.</a:t>
             </a:r>
           </a:p>
         </p:txBody>

</xml_diff>